<commit_message>
added slides draft 1
</commit_message>
<xml_diff>
--- a/docs/slides/foresight_pitch.pptx
+++ b/docs/slides/foresight_pitch.pptx
@@ -8,9 +8,11 @@
     <p:sldId id="256" r:id="rId2"/>
     <p:sldId id="257" r:id="rId3"/>
     <p:sldId id="258" r:id="rId4"/>
+    <p:sldId id="259" r:id="rId5"/>
+    <p:sldId id="260" r:id="rId6"/>
   </p:sldIdLst>
   <p:notesMasterIdLst>
-    <p:notesMasterId r:id="rId5"/>
+    <p:notesMasterId r:id="rId7"/>
   </p:notesMasterIdLst>
   <p:sldSz cx="12192000" cy="6858000"/>
   <p:notesSz cx="6858000" cy="12192000"/>
@@ -504,7 +506,7 @@
           <a:p>
             <a:r>
               <a:rPr lang="en-US" dirty="0"/>
-              <a:t>(~25 s) Hook. Foresight is a multi-agent system that watches a fintech platform's telemetry and predicts incidents before they breach, then investigates, decides and acts safely. The graph: a static threshold fires at the breach with zero warning; Foresight fires on the forecast. Then hand over: 'Here's why this matters.' JUDGING: Innovation (forecast-triggered, agent-owned decisions).</a:t>
+              <a:t>(~15 s) Hook. Foresight is a multi-agent system that watches a fintech platform's telemetry and predicts incidents before they breach, then investigates, decides and acts safely. A static threshold fires at the breach with zero warning; Foresight fires on the forecast. JUDGING: Innovation.</a:t>
             </a:r>
             <a:endParaRPr lang="en-US" dirty="0"/>
           </a:p>
@@ -592,7 +594,7 @@
           <a:p>
             <a:r>
               <a:rPr lang="en-US" dirty="0"/>
-              <a:t>(~60 s) Business gap. Cite three facts: PagerDuty 2024 survey, about $4,537 per minute of downtime; average incident 175 minutes, so roughly $794K each. Parametrix's CrowdStrike model puts banking at about $1.15B in direct losses across the Fortune 500. Gap: today's tools alert after the threshold is crossed (zero warning), and noisy pages cause alert fatigue; on the provided dataset 44% of critical pages were false. Nobody closes the loop from predict to investigate to act safely. These are survey/model estimates, say so. JUDGING: Real-world impact (genuine, measurable problem), Innovation (the gap).</a:t>
+              <a:t>(~45 s) Business gap. PagerDuty's 2024 survey puts downtime at about $4,537 per minute; an average incident runs 175 minutes, so roughly $794K each. Parametrix's CrowdStrike model puts banking at about $1.15B in direct losses across the Fortune 500. These are survey/model estimates, say so. Gap: tools alert after the threshold is crossed (zero warning) and noisy pages breed alert fatigue; on our dataset 44% of critical pages were false. Nobody closes the loop from predict to investigate to act safely. JUDGING: Real-world impact, Innovation.</a:t>
             </a:r>
             <a:endParaRPr lang="en-US" dirty="0"/>
           </a:p>
@@ -680,7 +682,7 @@
           <a:p>
             <a:r>
               <a:rPr lang="en-US" dirty="0"/>
-              <a:t>(~2 min, then hand over to live demo) Left: what we built. Commander agent sets a goal, plans, re-plans when the Skeptic disputes, acts through a deterministic Policy Guard, then verifies the outcome. Detection is forecast-based (time-to-breach) so we alert before the breach; the Skeptic cuts false positives; root-cause summaries cite evidence IDs and similar past incidents. Right: the three project metrics judges asked for: detection lead time, false-positive rate, root-cause summary quality. Fill the placeholders only from run_eval.py on held-out days (never hand-typed). Bottom: scalability path prototype to MVP to market-ready (blueprint section 21). Then: 'Let me show it live.' JUDGING: Functionality (live demo next), Technical execution (agent design, Policy Guard, GCP), Scalability (strip), Real-world impact (right side), Innovation (Skeptic + forecast + safe autonomy).</a:t>
+              <a:t>(~60 s) Left: what we built. Commander agent sets a goal, plans, re-plans when the Skeptic disputes, acts through a deterministic Policy Guard, then verifies the outcome. Detection is forecast-based so we alert before the breach; the Skeptic cuts false positives; root-cause summaries cite evidence IDs and similar past incidents. Right: the three project metrics: detection lead time, false-positive rate, root-cause summary quality. Fill placeholders only from run_eval.py on held-out days. JUDGING: Functionality, Real-world impact, Innovation.</a:t>
             </a:r>
             <a:endParaRPr lang="en-US" dirty="0"/>
           </a:p>
@@ -704,6 +706,182 @@
             <a:fld id="{F7021451-1387-4CA6-816F-3879F97B5CBC}" type="slidenum">
               <a:rPr lang="en-US"/>
               <a:t>3</a:t>
+            </a:fld>
+            <a:endParaRPr lang="en-US"/>
+          </a:p>
+        </p:txBody>
+      </p:sp>
+    </p:spTree>
+    <p:extLst>
+      <p:ext uri="{BB962C8B-B14F-4D97-AF65-F5344CB8AC3E}">
+        <p14:creationId xmlns:p14="http://schemas.microsoft.com/office/powerpoint/2010/main" val="1024086991"/>
+      </p:ext>
+    </p:extLst>
+  </p:cSld>
+  <p:clrMapOvr>
+    <a:masterClrMapping/>
+  </p:clrMapOvr>
+</p:notes>
+</file>
+
+<file path=ppt/notesSlides/notesSlide4.xml><?xml version="1.0" encoding="utf-8"?>
+<p:notes xmlns:a="http://schemas.openxmlformats.org/drawingml/2006/main" xmlns:r="http://schemas.openxmlformats.org/officeDocument/2006/relationships" xmlns:p="http://schemas.openxmlformats.org/presentationml/2006/main">
+  <p:cSld>
+    <p:spTree>
+      <p:nvGrpSpPr>
+        <p:cNvPr id="1" name=""/>
+        <p:cNvGrpSpPr/>
+        <p:nvPr/>
+      </p:nvGrpSpPr>
+      <p:grpSpPr>
+        <a:xfrm>
+          <a:off x="0" y="0"/>
+          <a:ext cx="0" cy="0"/>
+          <a:chOff x="0" y="0"/>
+          <a:chExt cx="0" cy="0"/>
+        </a:xfrm>
+      </p:grpSpPr>
+      <p:sp>
+        <p:nvSpPr>
+          <p:cNvPr id="2" name="Slide Image Placeholder 1"/>
+          <p:cNvSpPr>
+            <a:spLocks noGrp="1" noRot="1" noChangeAspect="1"/>
+          </p:cNvSpPr>
+          <p:nvPr>
+            <p:ph type="sldImg"/>
+          </p:nvPr>
+        </p:nvSpPr>
+        <p:spPr/>
+      </p:sp>
+      <p:sp>
+        <p:nvSpPr>
+          <p:cNvPr id="3" name="Notes Placeholder 2"/>
+          <p:cNvSpPr>
+            <a:spLocks noGrp="1"/>
+          </p:cNvSpPr>
+          <p:nvPr>
+            <p:ph type="body" idx="1"/>
+          </p:nvPr>
+        </p:nvSpPr>
+        <p:spPr/>
+        <p:txBody>
+          <a:bodyPr/>
+          <a:lstStyle/>
+          <a:p>
+            <a:r>
+              <a:rPr lang="en-US" dirty="0"/>
+              <a:t>(~50 s) Technical execution. Cheap statistical and ML layers only raise signals; they never act. The Incident Commander agent sets a goal, plans, delegates to specialists (Investigator, Historian with RAG, Skeptic, Log Analyst, Security Sentinel, Follow-up) and re-plans when evidence conflicts. Every decision passes a deterministic Policy Guard: an LLM mistake can make us not act, never act wrongly. If the LLM fails the system degrades to classic alerting, never silence. Stack: Python/FastAPI with the OpenAI Agents SDK, Next.js, Pub/Sub, BigQuery, Vertex AI, Cloud Run. Fill build status from the plan's phase tracker. JUDGING: Technical execution, Innovation.</a:t>
+            </a:r>
+            <a:endParaRPr lang="en-US" dirty="0"/>
+          </a:p>
+        </p:txBody>
+      </p:sp>
+      <p:sp>
+        <p:nvSpPr>
+          <p:cNvPr id="4" name="Slide Number Placeholder 3"/>
+          <p:cNvSpPr>
+            <a:spLocks noGrp="1"/>
+          </p:cNvSpPr>
+          <p:nvPr>
+            <p:ph type="sldNum" sz="quarter" idx="10"/>
+          </p:nvPr>
+        </p:nvSpPr>
+        <p:spPr/>
+        <p:txBody>
+          <a:bodyPr/>
+          <a:lstStyle/>
+          <a:p>
+            <a:fld id="{F7021451-1387-4CA6-816F-3879F97B5CBC}" type="slidenum">
+              <a:rPr lang="en-US"/>
+              <a:t>4</a:t>
+            </a:fld>
+            <a:endParaRPr lang="en-US"/>
+          </a:p>
+        </p:txBody>
+      </p:sp>
+    </p:spTree>
+    <p:extLst>
+      <p:ext uri="{BB962C8B-B14F-4D97-AF65-F5344CB8AC3E}">
+        <p14:creationId xmlns:p14="http://schemas.microsoft.com/office/powerpoint/2010/main" val="1024086991"/>
+      </p:ext>
+    </p:extLst>
+  </p:cSld>
+  <p:clrMapOvr>
+    <a:masterClrMapping/>
+  </p:clrMapOvr>
+</p:notes>
+</file>
+
+<file path=ppt/notesSlides/notesSlide5.xml><?xml version="1.0" encoding="utf-8"?>
+<p:notes xmlns:a="http://schemas.openxmlformats.org/drawingml/2006/main" xmlns:r="http://schemas.openxmlformats.org/officeDocument/2006/relationships" xmlns:p="http://schemas.openxmlformats.org/presentationml/2006/main">
+  <p:cSld>
+    <p:spTree>
+      <p:nvGrpSpPr>
+        <p:cNvPr id="1" name=""/>
+        <p:cNvGrpSpPr/>
+        <p:nvPr/>
+      </p:nvGrpSpPr>
+      <p:grpSpPr>
+        <a:xfrm>
+          <a:off x="0" y="0"/>
+          <a:ext cx="0" cy="0"/>
+          <a:chOff x="0" y="0"/>
+          <a:chExt cx="0" cy="0"/>
+        </a:xfrm>
+      </p:grpSpPr>
+      <p:sp>
+        <p:nvSpPr>
+          <p:cNvPr id="2" name="Slide Image Placeholder 1"/>
+          <p:cNvSpPr>
+            <a:spLocks noGrp="1" noRot="1" noChangeAspect="1"/>
+          </p:cNvSpPr>
+          <p:nvPr>
+            <p:ph type="sldImg"/>
+          </p:nvPr>
+        </p:nvSpPr>
+        <p:spPr/>
+      </p:sp>
+      <p:sp>
+        <p:nvSpPr>
+          <p:cNvPr id="3" name="Notes Placeholder 2"/>
+          <p:cNvSpPr>
+            <a:spLocks noGrp="1"/>
+          </p:cNvSpPr>
+          <p:nvPr>
+            <p:ph type="body" idx="1"/>
+          </p:nvPr>
+        </p:nvSpPr>
+        <p:spPr/>
+        <p:txBody>
+          <a:bodyPr/>
+          <a:lstStyle/>
+          <a:p>
+            <a:r>
+              <a:rPr lang="en-US" dirty="0"/>
+              <a:t>(~30 s, then 'let me show it live') Scalability: prototype today, MVP with multi-tenancy, Dataflow and Google ADK, market-ready with SOC 2 and per-tenant models. Throughput figures are targets from the design, not measurements. Close with the five criteria and hand over to the live demo. JUDGING: Scalability, plus a recap of all five.</a:t>
+            </a:r>
+            <a:endParaRPr lang="en-US" dirty="0"/>
+          </a:p>
+        </p:txBody>
+      </p:sp>
+      <p:sp>
+        <p:nvSpPr>
+          <p:cNvPr id="4" name="Slide Number Placeholder 3"/>
+          <p:cNvSpPr>
+            <a:spLocks noGrp="1"/>
+          </p:cNvSpPr>
+          <p:nvPr>
+            <p:ph type="sldNum" sz="quarter" idx="10"/>
+          </p:nvPr>
+        </p:nvSpPr>
+        <p:spPr/>
+        <p:txBody>
+          <a:bodyPr/>
+          <a:lstStyle/>
+          <a:p>
+            <a:fld id="{F7021451-1387-4CA6-816F-3879F97B5CBC}" type="slidenum">
+              <a:rPr lang="en-US"/>
+              <a:t>5</a:t>
             </a:fld>
             <a:endParaRPr lang="en-US"/>
           </a:p>
@@ -1158,7 +1336,7 @@
             <a:r>
               <a:rPr lang="en-US" sz="1600" b="1" dirty="0">
                 <a:solidFill>
-                  <a:srgbClr val="0F9D8A"/>
+                  <a:srgbClr val="2DD4BF"/>
                 </a:solidFill>
                 <a:latin typeface="Calibri" pitchFamily="34" charset="0"/>
                 <a:ea typeface="Calibri" pitchFamily="34" charset="-122"/>
@@ -1273,7 +1451,46 @@
       </p:sp>
       <p:sp>
         <p:nvSpPr>
-          <p:cNvPr id="8" name="Shape 6"/>
+          <p:cNvPr id="8" name="Text 6"/>
+          <p:cNvSpPr txBox="1"/>
+          <p:nvPr/>
+        </p:nvSpPr>
+        <p:spPr>
+          <a:xfrm>
+            <a:off x="7223760" y="2468880"/>
+            <a:ext cx="2377440" cy="274320"/>
+          </a:xfrm>
+          <a:prstGeom prst="rect">
+            <a:avLst/>
+          </a:prstGeom>
+          <a:noFill/>
+          <a:ln/>
+        </p:spPr>
+        <p:txBody>
+          <a:bodyPr wrap="square" lIns="0" tIns="0" rIns="0" bIns="0" rtlCol="0" anchor="ctr"/>
+          <a:lstStyle/>
+          <a:p>
+            <a:pPr algn="l" indent="0" marL="0">
+              <a:buNone/>
+            </a:pPr>
+            <a:r>
+              <a:rPr lang="en-US" sz="1200" dirty="0">
+                <a:solidFill>
+                  <a:srgbClr val="F87171"/>
+                </a:solidFill>
+                <a:latin typeface="Calibri" pitchFamily="34" charset="0"/>
+                <a:ea typeface="Calibri" pitchFamily="34" charset="-122"/>
+                <a:cs typeface="Calibri" pitchFamily="34" charset="-120"/>
+              </a:rPr>
+              <a:t>breach: 0 min warning</a:t>
+            </a:r>
+            <a:endParaRPr lang="en-US" sz="1200" dirty="0"/>
+          </a:p>
+        </p:txBody>
+      </p:sp>
+      <p:sp>
+        <p:nvSpPr>
+          <p:cNvPr id="9" name="Shape 7"/>
           <p:cNvSpPr/>
           <p:nvPr/>
         </p:nvSpPr>
@@ -1296,7 +1513,7 @@
       </p:sp>
       <p:sp>
         <p:nvSpPr>
-          <p:cNvPr id="9" name="Shape 7"/>
+          <p:cNvPr id="10" name="Shape 8"/>
           <p:cNvSpPr/>
           <p:nvPr/>
         </p:nvSpPr>
@@ -1319,7 +1536,7 @@
       </p:sp>
       <p:sp>
         <p:nvSpPr>
-          <p:cNvPr id="10" name="Shape 8"/>
+          <p:cNvPr id="11" name="Shape 9"/>
           <p:cNvSpPr/>
           <p:nvPr/>
         </p:nvSpPr>
@@ -1342,7 +1559,7 @@
       </p:sp>
       <p:sp>
         <p:nvSpPr>
-          <p:cNvPr id="11" name="Shape 9"/>
+          <p:cNvPr id="12" name="Shape 10"/>
           <p:cNvSpPr/>
           <p:nvPr/>
         </p:nvSpPr>
@@ -1365,7 +1582,7 @@
       </p:sp>
       <p:sp>
         <p:nvSpPr>
-          <p:cNvPr id="12" name="Shape 10"/>
+          <p:cNvPr id="13" name="Shape 11"/>
           <p:cNvSpPr/>
           <p:nvPr/>
         </p:nvSpPr>
@@ -1388,7 +1605,7 @@
       </p:sp>
       <p:sp>
         <p:nvSpPr>
-          <p:cNvPr id="13" name="Shape 11"/>
+          <p:cNvPr id="14" name="Shape 12"/>
           <p:cNvSpPr/>
           <p:nvPr/>
         </p:nvSpPr>
@@ -1411,7 +1628,7 @@
       </p:sp>
       <p:sp>
         <p:nvSpPr>
-          <p:cNvPr id="14" name="Shape 12"/>
+          <p:cNvPr id="15" name="Shape 13"/>
           <p:cNvSpPr/>
           <p:nvPr/>
         </p:nvSpPr>
@@ -1433,45 +1650,6 @@
             <a:prstDash val="solid"/>
           </a:ln>
         </p:spPr>
-      </p:sp>
-      <p:sp>
-        <p:nvSpPr>
-          <p:cNvPr id="15" name="Text 13"/>
-          <p:cNvSpPr txBox="1"/>
-          <p:nvPr/>
-        </p:nvSpPr>
-        <p:spPr>
-          <a:xfrm>
-            <a:off x="7223760" y="2468880"/>
-            <a:ext cx="2377440" cy="274320"/>
-          </a:xfrm>
-          <a:prstGeom prst="rect">
-            <a:avLst/>
-          </a:prstGeom>
-          <a:noFill/>
-          <a:ln/>
-        </p:spPr>
-        <p:txBody>
-          <a:bodyPr wrap="square" lIns="0" tIns="0" rIns="0" bIns="0" rtlCol="0" anchor="ctr"/>
-          <a:lstStyle/>
-          <a:p>
-            <a:pPr algn="l" indent="0" marL="0">
-              <a:buNone/>
-            </a:pPr>
-            <a:r>
-              <a:rPr lang="en-US" sz="1200" dirty="0">
-                <a:solidFill>
-                  <a:srgbClr val="F87171"/>
-                </a:solidFill>
-                <a:latin typeface="Calibri" pitchFamily="34" charset="0"/>
-                <a:ea typeface="Calibri" pitchFamily="34" charset="-122"/>
-                <a:cs typeface="Calibri" pitchFamily="34" charset="-120"/>
-              </a:rPr>
-              <a:t>breach: 0 min warning</a:t>
-            </a:r>
-            <a:endParaRPr lang="en-US" sz="1200" dirty="0"/>
-          </a:p>
-        </p:txBody>
       </p:sp>
       <p:sp>
         <p:nvSpPr>
@@ -2935,7 +3113,7 @@
         </p:blipFill>
         <p:spPr>
           <a:xfrm>
-            <a:off x="548640" y="1371600"/>
+            <a:off x="548640" y="1417320"/>
             <a:ext cx="310896" cy="310896"/>
           </a:xfrm>
           <a:prstGeom prst="rect">
@@ -2951,7 +3129,7 @@
         </p:nvSpPr>
         <p:spPr>
           <a:xfrm>
-            <a:off x="1005840" y="1344168"/>
+            <a:off x="1005840" y="1389888"/>
             <a:ext cx="2743200" cy="365760"/>
           </a:xfrm>
           <a:prstGeom prst="rect">
@@ -2990,8 +3168,8 @@
         </p:nvSpPr>
         <p:spPr>
           <a:xfrm>
-            <a:off x="548640" y="1874520"/>
-            <a:ext cx="5271516" cy="3200400"/>
+            <a:off x="548640" y="1965960"/>
+            <a:ext cx="5271516" cy="3840480"/>
           </a:xfrm>
           <a:prstGeom prst="rect">
             <a:avLst/>
@@ -3005,13 +3183,13 @@
           <a:p>
             <a:pPr marL="228600" indent="-228600">
               <a:spcAft>
-                <a:spcPts val="900"/>
+                <a:spcPts val="1200"/>
               </a:spcAft>
               <a:buSzPct val="100000"/>
               <a:buChar char="•"/>
             </a:pPr>
             <a:r>
-              <a:rPr lang="en-US" sz="1500" b="1" dirty="0">
+              <a:rPr lang="en-US" sz="1600" b="1" dirty="0">
                 <a:solidFill>
                   <a:srgbClr val="0F172A"/>
                 </a:solidFill>
@@ -3023,12 +3201,12 @@
             </a:r>
             <a:pPr indent="0" marL="0">
               <a:spcAft>
-                <a:spcPts val="900"/>
+                <a:spcPts val="1200"/>
               </a:spcAft>
               <a:buNone/>
             </a:pPr>
             <a:r>
-              <a:rPr lang="en-US" sz="1500" dirty="0">
+              <a:rPr lang="en-US" sz="1600" dirty="0">
                 <a:solidFill>
                   <a:srgbClr val="475569"/>
                 </a:solidFill>
@@ -3038,18 +3216,18 @@
               </a:rPr>
               <a:t>Commander plans, re-plans, acts, then verifies</a:t>
             </a:r>
-            <a:endParaRPr lang="en-US" sz="1500" dirty="0"/>
+            <a:endParaRPr lang="en-US" sz="1600" dirty="0"/>
           </a:p>
           <a:p>
             <a:pPr marL="228600" indent="-228600">
               <a:spcAft>
-                <a:spcPts val="900"/>
+                <a:spcPts val="1200"/>
               </a:spcAft>
               <a:buSzPct val="100000"/>
               <a:buChar char="•"/>
             </a:pPr>
             <a:r>
-              <a:rPr lang="en-US" sz="1500" b="1" dirty="0">
+              <a:rPr lang="en-US" sz="1600" b="1" dirty="0">
                 <a:solidFill>
                   <a:srgbClr val="0F172A"/>
                 </a:solidFill>
@@ -3061,12 +3239,12 @@
             </a:r>
             <a:pPr indent="0" marL="0">
               <a:spcAft>
-                <a:spcPts val="900"/>
+                <a:spcPts val="1200"/>
               </a:spcAft>
               <a:buNone/>
             </a:pPr>
             <a:r>
-              <a:rPr lang="en-US" sz="1500" dirty="0">
+              <a:rPr lang="en-US" sz="1600" dirty="0">
                 <a:solidFill>
                   <a:srgbClr val="475569"/>
                 </a:solidFill>
@@ -3076,18 +3254,18 @@
               </a:rPr>
               <a:t>EWMA + Holt time-to-breach + ML risk score</a:t>
             </a:r>
-            <a:endParaRPr lang="en-US" sz="1500" dirty="0"/>
+            <a:endParaRPr lang="en-US" sz="1600" dirty="0"/>
           </a:p>
           <a:p>
             <a:pPr marL="228600" indent="-228600">
               <a:spcAft>
-                <a:spcPts val="900"/>
+                <a:spcPts val="1200"/>
               </a:spcAft>
               <a:buSzPct val="100000"/>
               <a:buChar char="•"/>
             </a:pPr>
             <a:r>
-              <a:rPr lang="en-US" sz="1500" b="1" dirty="0">
+              <a:rPr lang="en-US" sz="1600" b="1" dirty="0">
                 <a:solidFill>
                   <a:srgbClr val="0F172A"/>
                 </a:solidFill>
@@ -3099,12 +3277,12 @@
             </a:r>
             <a:pPr indent="0" marL="0">
               <a:spcAft>
-                <a:spcPts val="900"/>
+                <a:spcPts val="1200"/>
               </a:spcAft>
               <a:buNone/>
             </a:pPr>
             <a:r>
-              <a:rPr lang="en-US" sz="1500" dirty="0">
+              <a:rPr lang="en-US" sz="1600" dirty="0">
                 <a:solidFill>
                   <a:srgbClr val="475569"/>
                 </a:solidFill>
@@ -3114,18 +3292,18 @@
               </a:rPr>
               <a:t>argues against alerts to cut false pages</a:t>
             </a:r>
-            <a:endParaRPr lang="en-US" sz="1500" dirty="0"/>
+            <a:endParaRPr lang="en-US" sz="1600" dirty="0"/>
           </a:p>
           <a:p>
             <a:pPr marL="228600" indent="-228600">
               <a:spcAft>
-                <a:spcPts val="900"/>
+                <a:spcPts val="1200"/>
               </a:spcAft>
               <a:buSzPct val="100000"/>
               <a:buChar char="•"/>
             </a:pPr>
             <a:r>
-              <a:rPr lang="en-US" sz="1500" b="1" dirty="0">
+              <a:rPr lang="en-US" sz="1600" b="1" dirty="0">
                 <a:solidFill>
                   <a:srgbClr val="0F172A"/>
                 </a:solidFill>
@@ -3137,12 +3315,12 @@
             </a:r>
             <a:pPr indent="0" marL="0">
               <a:spcAft>
-                <a:spcPts val="900"/>
+                <a:spcPts val="1200"/>
               </a:spcAft>
               <a:buNone/>
             </a:pPr>
             <a:r>
-              <a:rPr lang="en-US" sz="1500" dirty="0">
+              <a:rPr lang="en-US" sz="1600" dirty="0">
                 <a:solidFill>
                   <a:srgbClr val="475569"/>
                 </a:solidFill>
@@ -3152,18 +3330,18 @@
               </a:rPr>
               <a:t>evidence IDs, RAG over past incidents</a:t>
             </a:r>
-            <a:endParaRPr lang="en-US" sz="1500" dirty="0"/>
+            <a:endParaRPr lang="en-US" sz="1600" dirty="0"/>
           </a:p>
           <a:p>
             <a:pPr marL="228600" indent="-228600">
               <a:spcAft>
-                <a:spcPts val="900"/>
+                <a:spcPts val="1200"/>
               </a:spcAft>
               <a:buSzPct val="100000"/>
               <a:buChar char="•"/>
             </a:pPr>
             <a:r>
-              <a:rPr lang="en-US" sz="1500" b="1" dirty="0">
+              <a:rPr lang="en-US" sz="1600" b="1" dirty="0">
                 <a:solidFill>
                   <a:srgbClr val="0F172A"/>
                 </a:solidFill>
@@ -3175,12 +3353,12 @@
             </a:r>
             <a:pPr indent="0" marL="0">
               <a:spcAft>
-                <a:spcPts val="900"/>
+                <a:spcPts val="1200"/>
               </a:spcAft>
               <a:buNone/>
             </a:pPr>
             <a:r>
-              <a:rPr lang="en-US" sz="1500" dirty="0">
+              <a:rPr lang="en-US" sz="1600" dirty="0">
                 <a:solidFill>
                   <a:srgbClr val="475569"/>
                 </a:solidFill>
@@ -3190,18 +3368,18 @@
               </a:rPr>
               <a:t>Policy Guard, TTL, rollback; humans approve risky actions</a:t>
             </a:r>
-            <a:endParaRPr lang="en-US" sz="1500" dirty="0"/>
+            <a:endParaRPr lang="en-US" sz="1600" dirty="0"/>
           </a:p>
           <a:p>
             <a:pPr marL="228600" indent="-228600">
               <a:spcAft>
-                <a:spcPts val="900"/>
+                <a:spcPts val="1200"/>
               </a:spcAft>
               <a:buSzPct val="100000"/>
               <a:buChar char="•"/>
             </a:pPr>
             <a:r>
-              <a:rPr lang="en-US" sz="1500" b="1" dirty="0">
+              <a:rPr lang="en-US" sz="1600" b="1" dirty="0">
                 <a:solidFill>
                   <a:srgbClr val="0F172A"/>
                 </a:solidFill>
@@ -3213,12 +3391,12 @@
             </a:r>
             <a:pPr indent="0" marL="0">
               <a:spcAft>
-                <a:spcPts val="900"/>
+                <a:spcPts val="1200"/>
               </a:spcAft>
               <a:buNone/>
             </a:pPr>
             <a:r>
-              <a:rPr lang="en-US" sz="1500" dirty="0">
+              <a:rPr lang="en-US" sz="1600" dirty="0">
                 <a:solidFill>
                   <a:srgbClr val="475569"/>
                 </a:solidFill>
@@ -3228,7 +3406,7 @@
               </a:rPr>
               <a:t>FinPay simulator, live chaos demo, GCP deployed [status]</a:t>
             </a:r>
-            <a:endParaRPr lang="en-US" sz="1500" dirty="0"/>
+            <a:endParaRPr lang="en-US" sz="1600" dirty="0"/>
           </a:p>
         </p:txBody>
       </p:sp>
@@ -3248,7 +3426,7 @@
         </p:blipFill>
         <p:spPr>
           <a:xfrm>
-            <a:off x="6368796" y="1371600"/>
+            <a:off x="6368796" y="1417320"/>
             <a:ext cx="310896" cy="310896"/>
           </a:xfrm>
           <a:prstGeom prst="rect">
@@ -3264,7 +3442,7 @@
         </p:nvSpPr>
         <p:spPr>
           <a:xfrm>
-            <a:off x="6825996" y="1344168"/>
+            <a:off x="6825996" y="1389888"/>
             <a:ext cx="4572000" cy="365760"/>
           </a:xfrm>
           <a:prstGeom prst="rect">
@@ -3303,12 +3481,12 @@
         </p:nvSpPr>
         <p:spPr>
           <a:xfrm>
-            <a:off x="6368796" y="1874520"/>
-            <a:ext cx="1635252" cy="1600200"/>
+            <a:off x="6368796" y="1965960"/>
+            <a:ext cx="1635252" cy="1737360"/>
           </a:xfrm>
           <a:prstGeom prst="roundRect">
             <a:avLst>
-              <a:gd name="adj" fmla="val 5714"/>
+              <a:gd name="adj" fmla="val 5592"/>
             </a:avLst>
           </a:prstGeom>
           <a:solidFill>
@@ -3330,7 +3508,7 @@
         </p:nvSpPr>
         <p:spPr>
           <a:xfrm>
-            <a:off x="6505956" y="2057400"/>
+            <a:off x="6505956" y="2148840"/>
             <a:ext cx="1360932" cy="594360"/>
           </a:xfrm>
           <a:prstGeom prst="rect">
@@ -3369,7 +3547,7 @@
         </p:nvSpPr>
         <p:spPr>
           <a:xfrm>
-            <a:off x="6505956" y="2679192"/>
+            <a:off x="6505956" y="2807208"/>
             <a:ext cx="1360932" cy="365760"/>
           </a:xfrm>
           <a:prstGeom prst="rect">
@@ -3408,7 +3586,7 @@
         </p:nvSpPr>
         <p:spPr>
           <a:xfrm>
-            <a:off x="6505956" y="3063240"/>
+            <a:off x="6505956" y="3246120"/>
             <a:ext cx="1360932" cy="320040"/>
           </a:xfrm>
           <a:prstGeom prst="rect">
@@ -3447,12 +3625,12 @@
         </p:nvSpPr>
         <p:spPr>
           <a:xfrm>
-            <a:off x="8186928" y="1874520"/>
-            <a:ext cx="1635252" cy="1600200"/>
+            <a:off x="8186928" y="1965960"/>
+            <a:ext cx="1635252" cy="1737360"/>
           </a:xfrm>
           <a:prstGeom prst="roundRect">
             <a:avLst>
-              <a:gd name="adj" fmla="val 5714"/>
+              <a:gd name="adj" fmla="val 5592"/>
             </a:avLst>
           </a:prstGeom>
           <a:solidFill>
@@ -3474,7 +3652,7 @@
         </p:nvSpPr>
         <p:spPr>
           <a:xfrm>
-            <a:off x="8324088" y="2057400"/>
+            <a:off x="8324088" y="2148840"/>
             <a:ext cx="1360932" cy="594360"/>
           </a:xfrm>
           <a:prstGeom prst="rect">
@@ -3513,7 +3691,7 @@
         </p:nvSpPr>
         <p:spPr>
           <a:xfrm>
-            <a:off x="8324088" y="2679192"/>
+            <a:off x="8324088" y="2807208"/>
             <a:ext cx="1360932" cy="365760"/>
           </a:xfrm>
           <a:prstGeom prst="rect">
@@ -3552,7 +3730,7 @@
         </p:nvSpPr>
         <p:spPr>
           <a:xfrm>
-            <a:off x="8324088" y="3063240"/>
+            <a:off x="8324088" y="3246120"/>
             <a:ext cx="1360932" cy="320040"/>
           </a:xfrm>
           <a:prstGeom prst="rect">
@@ -3591,12 +3769,12 @@
         </p:nvSpPr>
         <p:spPr>
           <a:xfrm>
-            <a:off x="10005060" y="1874520"/>
-            <a:ext cx="1635252" cy="1600200"/>
+            <a:off x="10005060" y="1965960"/>
+            <a:ext cx="1635252" cy="1737360"/>
           </a:xfrm>
           <a:prstGeom prst="roundRect">
             <a:avLst>
-              <a:gd name="adj" fmla="val 5714"/>
+              <a:gd name="adj" fmla="val 5592"/>
             </a:avLst>
           </a:prstGeom>
           <a:solidFill>
@@ -3618,7 +3796,7 @@
         </p:nvSpPr>
         <p:spPr>
           <a:xfrm>
-            <a:off x="10142220" y="2057400"/>
+            <a:off x="10142220" y="2148840"/>
             <a:ext cx="1360932" cy="594360"/>
           </a:xfrm>
           <a:prstGeom prst="rect">
@@ -3657,7 +3835,7 @@
         </p:nvSpPr>
         <p:spPr>
           <a:xfrm>
-            <a:off x="10142220" y="2679192"/>
+            <a:off x="10142220" y="2807208"/>
             <a:ext cx="1360932" cy="365760"/>
           </a:xfrm>
           <a:prstGeom prst="rect">
@@ -3696,7 +3874,7 @@
         </p:nvSpPr>
         <p:spPr>
           <a:xfrm>
-            <a:off x="10142220" y="3063240"/>
+            <a:off x="10142220" y="3246120"/>
             <a:ext cx="1360932" cy="320040"/>
           </a:xfrm>
           <a:prstGeom prst="rect">
@@ -3735,8 +3913,8 @@
         </p:nvSpPr>
         <p:spPr>
           <a:xfrm>
-            <a:off x="6368796" y="3703320"/>
-            <a:ext cx="5271516" cy="1371600"/>
+            <a:off x="6368796" y="3977640"/>
+            <a:ext cx="5271516" cy="1554480"/>
           </a:xfrm>
           <a:prstGeom prst="rect">
             <a:avLst/>
@@ -3750,13 +3928,13 @@
           <a:p>
             <a:pPr marL="228600" indent="-228600">
               <a:spcAft>
-                <a:spcPts val="900"/>
+                <a:spcPts val="1200"/>
               </a:spcAft>
               <a:buSzPct val="100000"/>
               <a:buChar char="•"/>
             </a:pPr>
             <a:r>
-              <a:rPr lang="en-US" sz="1500" b="1" dirty="0">
+              <a:rPr lang="en-US" sz="1600" b="1" dirty="0">
                 <a:solidFill>
                   <a:srgbClr val="B45309"/>
                 </a:solidFill>
@@ -3768,12 +3946,12 @@
             </a:r>
             <a:pPr indent="0" marL="0">
               <a:spcAft>
-                <a:spcPts val="900"/>
+                <a:spcPts val="1200"/>
               </a:spcAft>
               <a:buNone/>
             </a:pPr>
             <a:r>
-              <a:rPr lang="en-US" sz="1500" dirty="0">
+              <a:rPr lang="en-US" sz="1600" dirty="0">
                 <a:solidFill>
                   <a:srgbClr val="475569"/>
                 </a:solidFill>
@@ -3783,18 +3961,18 @@
               </a:rPr>
               <a:t>downtime avoided per prevented incident</a:t>
             </a:r>
-            <a:endParaRPr lang="en-US" sz="1500" dirty="0"/>
+            <a:endParaRPr lang="en-US" sz="1600" dirty="0"/>
           </a:p>
           <a:p>
             <a:pPr marL="228600" indent="-228600">
               <a:spcAft>
-                <a:spcPts val="900"/>
+                <a:spcPts val="1200"/>
               </a:spcAft>
               <a:buSzPct val="100000"/>
               <a:buChar char="•"/>
             </a:pPr>
             <a:r>
-              <a:rPr lang="en-US" sz="1500" b="1" dirty="0">
+              <a:rPr lang="en-US" sz="1600" b="1" dirty="0">
                 <a:solidFill>
                   <a:srgbClr val="B45309"/>
                 </a:solidFill>
@@ -3806,12 +3984,12 @@
             </a:r>
             <a:pPr indent="0" marL="0">
               <a:spcAft>
-                <a:spcPts val="900"/>
+                <a:spcPts val="1200"/>
               </a:spcAft>
               <a:buNone/>
             </a:pPr>
             <a:r>
-              <a:rPr lang="en-US" sz="1500" dirty="0">
+              <a:rPr lang="en-US" sz="1600" dirty="0">
                 <a:solidFill>
                   <a:srgbClr val="475569"/>
                 </a:solidFill>
@@ -3821,18 +3999,18 @@
               </a:rPr>
               <a:t>of incidents ticketed before the first customer report</a:t>
             </a:r>
-            <a:endParaRPr lang="en-US" sz="1500" dirty="0"/>
+            <a:endParaRPr lang="en-US" sz="1600" dirty="0"/>
           </a:p>
           <a:p>
             <a:pPr marL="228600" indent="-228600">
               <a:spcAft>
-                <a:spcPts val="900"/>
+                <a:spcPts val="1200"/>
               </a:spcAft>
               <a:buSzPct val="100000"/>
               <a:buChar char="•"/>
             </a:pPr>
             <a:r>
-              <a:rPr lang="en-US" sz="1500" b="1" dirty="0">
+              <a:rPr lang="en-US" sz="1600" b="1" dirty="0">
                 <a:solidFill>
                   <a:srgbClr val="B45309"/>
                 </a:solidFill>
@@ -3844,12 +4022,12 @@
             </a:r>
             <a:pPr indent="0" marL="0">
               <a:spcAft>
-                <a:spcPts val="900"/>
+                <a:spcPts val="1200"/>
               </a:spcAft>
               <a:buNone/>
             </a:pPr>
             <a:r>
-              <a:rPr lang="en-US" sz="1500" dirty="0">
+              <a:rPr lang="en-US" sz="1600" dirty="0">
                 <a:solidFill>
                   <a:srgbClr val="475569"/>
                 </a:solidFill>
@@ -3859,24 +4037,440 @@
               </a:rPr>
               <a:t>lower MTTR; every action audited and reversible</a:t>
             </a:r>
-            <a:endParaRPr lang="en-US" sz="1500" dirty="0"/>
-          </a:p>
-        </p:txBody>
-      </p:sp>
-      <p:sp>
-        <p:nvSpPr>
-          <p:cNvPr id="21" name="Scale 1"/>
+            <a:endParaRPr lang="en-US" sz="1600" dirty="0"/>
+          </a:p>
+        </p:txBody>
+      </p:sp>
+      <p:sp>
+        <p:nvSpPr>
+          <p:cNvPr id="21" name="Text 17"/>
+          <p:cNvSpPr txBox="1"/>
+          <p:nvPr/>
+        </p:nvSpPr>
+        <p:spPr>
+          <a:xfrm>
+            <a:off x="548640" y="6126480"/>
+            <a:ext cx="11091672" cy="274320"/>
+          </a:xfrm>
+          <a:prstGeom prst="rect">
+            <a:avLst/>
+          </a:prstGeom>
+          <a:noFill/>
+          <a:ln/>
+        </p:spPr>
+        <p:txBody>
+          <a:bodyPr wrap="square" lIns="0" tIns="0" rIns="0" bIns="0" rtlCol="0" anchor="ctr"/>
+          <a:lstStyle/>
+          <a:p>
+            <a:pPr indent="0" marL="0">
+              <a:buNone/>
+            </a:pPr>
+            <a:r>
+              <a:rPr lang="en-US" sz="1100" i="1" dirty="0">
+                <a:solidFill>
+                  <a:srgbClr val="475569"/>
+                </a:solidFill>
+                <a:latin typeface="Calibri" pitchFamily="34" charset="0"/>
+                <a:ea typeface="Calibri" pitchFamily="34" charset="-122"/>
+                <a:cs typeface="Calibri" pitchFamily="34" charset="-120"/>
+              </a:rPr>
+              <a:t>Measured against a static-threshold baseline on held-out days only. Numbers come from the evaluation script, never hand-typed.</a:t>
+            </a:r>
+            <a:endParaRPr lang="en-US" sz="1100" dirty="0"/>
+          </a:p>
+        </p:txBody>
+      </p:sp>
+    </p:spTree>
+  </p:cSld>
+  <p:clrMapOvr>
+    <a:masterClrMapping/>
+  </p:clrMapOvr>
+</p:sld>
+</file>
+
+<file path=ppt/slides/slide4.xml><?xml version="1.0" encoding="utf-8"?>
+<p:sld xmlns:a="http://schemas.openxmlformats.org/drawingml/2006/main" xmlns:r="http://schemas.openxmlformats.org/officeDocument/2006/relationships" xmlns:p="http://schemas.openxmlformats.org/presentationml/2006/main">
+  <p:cSld name="Slide 4">
+    <p:bg>
+      <p:bgPr>
+        <a:solidFill>
+          <a:srgbClr val="FFFFFF"/>
+        </a:solidFill>
+      </p:bgPr>
+    </p:bg>
+    <p:spTree>
+      <p:nvGrpSpPr>
+        <p:cNvPr id="1" name=""/>
+        <p:cNvGrpSpPr/>
+        <p:nvPr/>
+      </p:nvGrpSpPr>
+      <p:grpSpPr>
+        <a:xfrm>
+          <a:off x="0" y="0"/>
+          <a:ext cx="0" cy="0"/>
+          <a:chOff x="0" y="0"/>
+          <a:chExt cx="0" cy="0"/>
+        </a:xfrm>
+      </p:grpSpPr>
+      <p:sp>
+        <p:nvSpPr>
+          <p:cNvPr id="2" name="Title"/>
+          <p:cNvSpPr txBox="1"/>
+          <p:nvPr/>
+        </p:nvSpPr>
+        <p:spPr>
+          <a:xfrm>
+            <a:off x="548640" y="411480"/>
+            <a:ext cx="11091672" cy="731520"/>
+          </a:xfrm>
+          <a:prstGeom prst="rect">
+            <a:avLst/>
+          </a:prstGeom>
+          <a:noFill/>
+          <a:ln/>
+        </p:spPr>
+        <p:txBody>
+          <a:bodyPr wrap="square" lIns="0" tIns="0" rIns="0" bIns="0" rtlCol="0" anchor="ctr"/>
+          <a:lstStyle/>
+          <a:p>
+            <a:pPr indent="0" marL="0">
+              <a:buNone/>
+            </a:pPr>
+            <a:r>
+              <a:rPr lang="en-US" sz="3600" b="1" dirty="0">
+                <a:solidFill>
+                  <a:srgbClr val="0F172A"/>
+                </a:solidFill>
+                <a:latin typeface="Calibri" pitchFamily="34" charset="0"/>
+                <a:ea typeface="Calibri" pitchFamily="34" charset="-122"/>
+                <a:cs typeface="Calibri" pitchFamily="34" charset="-120"/>
+              </a:rPr>
+              <a:t>Agents decide, code enforces the limits</a:t>
+            </a:r>
+            <a:endParaRPr lang="en-US" sz="3600" dirty="0"/>
+          </a:p>
+        </p:txBody>
+      </p:sp>
+      <p:sp>
+        <p:nvSpPr>
+          <p:cNvPr id="3" name="Stage 1"/>
           <p:cNvSpPr/>
           <p:nvPr/>
         </p:nvSpPr>
         <p:spPr>
           <a:xfrm>
-            <a:off x="548640" y="5623560"/>
-            <a:ext cx="3392424" cy="777240"/>
+            <a:off x="548640" y="1463040"/>
+            <a:ext cx="1889150" cy="1828800"/>
           </a:xfrm>
           <a:prstGeom prst="roundRect">
             <a:avLst>
-              <a:gd name="adj" fmla="val 11765"/>
+              <a:gd name="adj" fmla="val 6000"/>
+            </a:avLst>
+          </a:prstGeom>
+          <a:solidFill>
+            <a:srgbClr val="F1F5F9"/>
+          </a:solidFill>
+          <a:ln w="12700">
+            <a:solidFill>
+              <a:srgbClr val="F1F5F9"/>
+            </a:solidFill>
+            <a:prstDash val="solid"/>
+          </a:ln>
+        </p:spPr>
+      </p:sp>
+      <p:pic>
+        <p:nvPicPr>
+          <p:cNvPr id="4" name="Image 0" descr="preencoded.png">    </p:cNvPr>
+          <p:cNvPicPr>
+            <a:picLocks noChangeAspect="1"/>
+          </p:cNvPicPr>
+          <p:nvPr/>
+        </p:nvPicPr>
+        <p:blipFill>
+          <a:blip r:embed="rId1"/>
+          <a:stretch>
+            <a:fillRect/>
+          </a:stretch>
+        </p:blipFill>
+        <p:spPr>
+          <a:xfrm>
+            <a:off x="777240" y="1691640"/>
+            <a:ext cx="365760" cy="365760"/>
+          </a:xfrm>
+          <a:prstGeom prst="rect">
+            <a:avLst/>
+          </a:prstGeom>
+        </p:spPr>
+      </p:pic>
+      <p:sp>
+        <p:nvSpPr>
+          <p:cNvPr id="5" name="Text 2"/>
+          <p:cNvSpPr txBox="1"/>
+          <p:nvPr/>
+        </p:nvSpPr>
+        <p:spPr>
+          <a:xfrm>
+            <a:off x="777240" y="2194560"/>
+            <a:ext cx="1431950" cy="365760"/>
+          </a:xfrm>
+          <a:prstGeom prst="rect">
+            <a:avLst/>
+          </a:prstGeom>
+          <a:noFill/>
+          <a:ln/>
+        </p:spPr>
+        <p:txBody>
+          <a:bodyPr wrap="square" lIns="0" tIns="0" rIns="0" bIns="0" rtlCol="0" anchor="ctr"/>
+          <a:lstStyle/>
+          <a:p>
+            <a:pPr indent="0" marL="0">
+              <a:buNone/>
+            </a:pPr>
+            <a:r>
+              <a:rPr lang="en-US" sz="1800" b="1" dirty="0">
+                <a:solidFill>
+                  <a:srgbClr val="0F172A"/>
+                </a:solidFill>
+                <a:latin typeface="Calibri" pitchFamily="34" charset="0"/>
+                <a:ea typeface="Calibri" pitchFamily="34" charset="-122"/>
+                <a:cs typeface="Calibri" pitchFamily="34" charset="-120"/>
+              </a:rPr>
+              <a:t>Telemetry</a:t>
+            </a:r>
+            <a:endParaRPr lang="en-US" sz="1800" dirty="0"/>
+          </a:p>
+        </p:txBody>
+      </p:sp>
+      <p:sp>
+        <p:nvSpPr>
+          <p:cNvPr id="6" name="Text 3"/>
+          <p:cNvSpPr txBox="1"/>
+          <p:nvPr/>
+        </p:nvSpPr>
+        <p:spPr>
+          <a:xfrm>
+            <a:off x="777240" y="2560320"/>
+            <a:ext cx="1431950" cy="640080"/>
+          </a:xfrm>
+          <a:prstGeom prst="rect">
+            <a:avLst/>
+          </a:prstGeom>
+          <a:noFill/>
+          <a:ln/>
+        </p:spPr>
+        <p:txBody>
+          <a:bodyPr wrap="square" lIns="0" tIns="0" rIns="0" bIns="0" rtlCol="0" anchor="t"/>
+          <a:lstStyle/>
+          <a:p>
+            <a:pPr indent="0" marL="0">
+              <a:buNone/>
+            </a:pPr>
+            <a:r>
+              <a:rPr lang="en-US" sz="1200" dirty="0">
+                <a:solidFill>
+                  <a:srgbClr val="475569"/>
+                </a:solidFill>
+                <a:latin typeface="Calibri" pitchFamily="34" charset="0"/>
+                <a:ea typeface="Calibri" pitchFamily="34" charset="-122"/>
+                <a:cs typeface="Calibri" pitchFamily="34" charset="-120"/>
+              </a:rPr>
+              <a:t>metrics, logs, auth events, tickets</a:t>
+            </a:r>
+            <a:endParaRPr lang="en-US" sz="1200" dirty="0"/>
+          </a:p>
+        </p:txBody>
+      </p:sp>
+      <p:pic>
+        <p:nvPicPr>
+          <p:cNvPr id="7" name="Image 1" descr="preencoded.png">    </p:cNvPr>
+          <p:cNvPicPr>
+            <a:picLocks noChangeAspect="1"/>
+          </p:cNvPicPr>
+          <p:nvPr/>
+        </p:nvPicPr>
+        <p:blipFill>
+          <a:blip r:embed="rId2"/>
+          <a:stretch>
+            <a:fillRect/>
+          </a:stretch>
+        </p:blipFill>
+        <p:spPr>
+          <a:xfrm>
+            <a:off x="2529230" y="2267712"/>
+            <a:ext cx="219456" cy="219456"/>
+          </a:xfrm>
+          <a:prstGeom prst="rect">
+            <a:avLst/>
+          </a:prstGeom>
+        </p:spPr>
+      </p:pic>
+      <p:sp>
+        <p:nvSpPr>
+          <p:cNvPr id="8" name="Stage 2"/>
+          <p:cNvSpPr/>
+          <p:nvPr/>
+        </p:nvSpPr>
+        <p:spPr>
+          <a:xfrm>
+            <a:off x="2849270" y="1463040"/>
+            <a:ext cx="1889150" cy="1828800"/>
+          </a:xfrm>
+          <a:prstGeom prst="roundRect">
+            <a:avLst>
+              <a:gd name="adj" fmla="val 6000"/>
+            </a:avLst>
+          </a:prstGeom>
+          <a:solidFill>
+            <a:srgbClr val="F1F5F9"/>
+          </a:solidFill>
+          <a:ln w="12700">
+            <a:solidFill>
+              <a:srgbClr val="F1F5F9"/>
+            </a:solidFill>
+            <a:prstDash val="solid"/>
+          </a:ln>
+        </p:spPr>
+      </p:sp>
+      <p:pic>
+        <p:nvPicPr>
+          <p:cNvPr id="9" name="Image 2" descr="preencoded.png">    </p:cNvPr>
+          <p:cNvPicPr>
+            <a:picLocks noChangeAspect="1"/>
+          </p:cNvPicPr>
+          <p:nvPr/>
+        </p:nvPicPr>
+        <p:blipFill>
+          <a:blip r:embed="rId3"/>
+          <a:stretch>
+            <a:fillRect/>
+          </a:stretch>
+        </p:blipFill>
+        <p:spPr>
+          <a:xfrm>
+            <a:off x="3077870" y="1691640"/>
+            <a:ext cx="365760" cy="365760"/>
+          </a:xfrm>
+          <a:prstGeom prst="rect">
+            <a:avLst/>
+          </a:prstGeom>
+        </p:spPr>
+      </p:pic>
+      <p:sp>
+        <p:nvSpPr>
+          <p:cNvPr id="10" name="Text 5"/>
+          <p:cNvSpPr txBox="1"/>
+          <p:nvPr/>
+        </p:nvSpPr>
+        <p:spPr>
+          <a:xfrm>
+            <a:off x="3077870" y="2194560"/>
+            <a:ext cx="1431950" cy="365760"/>
+          </a:xfrm>
+          <a:prstGeom prst="rect">
+            <a:avLst/>
+          </a:prstGeom>
+          <a:noFill/>
+          <a:ln/>
+        </p:spPr>
+        <p:txBody>
+          <a:bodyPr wrap="square" lIns="0" tIns="0" rIns="0" bIns="0" rtlCol="0" anchor="ctr"/>
+          <a:lstStyle/>
+          <a:p>
+            <a:pPr indent="0" marL="0">
+              <a:buNone/>
+            </a:pPr>
+            <a:r>
+              <a:rPr lang="en-US" sz="1800" b="1" dirty="0">
+                <a:solidFill>
+                  <a:srgbClr val="0F172A"/>
+                </a:solidFill>
+                <a:latin typeface="Calibri" pitchFamily="34" charset="0"/>
+                <a:ea typeface="Calibri" pitchFamily="34" charset="-122"/>
+                <a:cs typeface="Calibri" pitchFamily="34" charset="-120"/>
+              </a:rPr>
+              <a:t>Signals</a:t>
+            </a:r>
+            <a:endParaRPr lang="en-US" sz="1800" dirty="0"/>
+          </a:p>
+        </p:txBody>
+      </p:sp>
+      <p:sp>
+        <p:nvSpPr>
+          <p:cNvPr id="11" name="Text 6"/>
+          <p:cNvSpPr txBox="1"/>
+          <p:nvPr/>
+        </p:nvSpPr>
+        <p:spPr>
+          <a:xfrm>
+            <a:off x="3077870" y="2560320"/>
+            <a:ext cx="1431950" cy="640080"/>
+          </a:xfrm>
+          <a:prstGeom prst="rect">
+            <a:avLst/>
+          </a:prstGeom>
+          <a:noFill/>
+          <a:ln/>
+        </p:spPr>
+        <p:txBody>
+          <a:bodyPr wrap="square" lIns="0" tIns="0" rIns="0" bIns="0" rtlCol="0" anchor="t"/>
+          <a:lstStyle/>
+          <a:p>
+            <a:pPr indent="0" marL="0">
+              <a:buNone/>
+            </a:pPr>
+            <a:r>
+              <a:rPr lang="en-US" sz="1200" dirty="0">
+                <a:solidFill>
+                  <a:srgbClr val="475569"/>
+                </a:solidFill>
+                <a:latin typeface="Calibri" pitchFamily="34" charset="0"/>
+                <a:ea typeface="Calibri" pitchFamily="34" charset="-122"/>
+                <a:cs typeface="Calibri" pitchFamily="34" charset="-120"/>
+              </a:rPr>
+              <a:t>EWMA, Holt time-to-breach, ML risk</a:t>
+            </a:r>
+            <a:endParaRPr lang="en-US" sz="1200" dirty="0"/>
+          </a:p>
+        </p:txBody>
+      </p:sp>
+      <p:pic>
+        <p:nvPicPr>
+          <p:cNvPr id="12" name="Image 3" descr="preencoded.png">    </p:cNvPr>
+          <p:cNvPicPr>
+            <a:picLocks noChangeAspect="1"/>
+          </p:cNvPicPr>
+          <p:nvPr/>
+        </p:nvPicPr>
+        <p:blipFill>
+          <a:blip r:embed="rId4"/>
+          <a:stretch>
+            <a:fillRect/>
+          </a:stretch>
+        </p:blipFill>
+        <p:spPr>
+          <a:xfrm>
+            <a:off x="4829861" y="2267712"/>
+            <a:ext cx="219456" cy="219456"/>
+          </a:xfrm>
+          <a:prstGeom prst="rect">
+            <a:avLst/>
+          </a:prstGeom>
+        </p:spPr>
+      </p:pic>
+      <p:sp>
+        <p:nvSpPr>
+          <p:cNvPr id="13" name="Stage 3"/>
+          <p:cNvSpPr/>
+          <p:nvPr/>
+        </p:nvSpPr>
+        <p:spPr>
+          <a:xfrm>
+            <a:off x="5149901" y="1463040"/>
+            <a:ext cx="1889150" cy="1828800"/>
+          </a:xfrm>
+          <a:prstGeom prst="roundRect">
+            <a:avLst>
+              <a:gd name="adj" fmla="val 6000"/>
             </a:avLst>
           </a:prstGeom>
           <a:solidFill>
@@ -3890,101 +4484,125 @@
           </a:ln>
         </p:spPr>
       </p:sp>
-      <p:sp>
-        <p:nvSpPr>
-          <p:cNvPr id="22" name="Text 18"/>
-          <p:cNvSpPr txBox="1"/>
-          <p:nvPr/>
-        </p:nvSpPr>
-        <p:spPr>
-          <a:xfrm>
-            <a:off x="731520" y="5715000"/>
-            <a:ext cx="3026664" cy="274320"/>
-          </a:xfrm>
-          <a:prstGeom prst="rect">
-            <a:avLst/>
-          </a:prstGeom>
-          <a:noFill/>
-          <a:ln/>
-        </p:spPr>
-        <p:txBody>
-          <a:bodyPr wrap="square" lIns="0" tIns="0" rIns="0" bIns="0" rtlCol="0" anchor="ctr"/>
-          <a:lstStyle/>
-          <a:p>
-            <a:pPr indent="0" marL="0">
-              <a:buNone/>
-            </a:pPr>
-            <a:r>
-              <a:rPr lang="en-US" sz="1400" b="1" dirty="0">
-                <a:solidFill>
-                  <a:srgbClr val="FFFFFF"/>
-                </a:solidFill>
-                <a:latin typeface="Calibri" pitchFamily="34" charset="0"/>
-                <a:ea typeface="Calibri" pitchFamily="34" charset="-122"/>
-                <a:cs typeface="Calibri" pitchFamily="34" charset="-120"/>
-              </a:rPr>
-              <a:t>Prototype (today)</a:t>
-            </a:r>
-            <a:endParaRPr lang="en-US" sz="1400" dirty="0"/>
-          </a:p>
-        </p:txBody>
-      </p:sp>
-      <p:sp>
-        <p:nvSpPr>
-          <p:cNvPr id="23" name="Text 19"/>
-          <p:cNvSpPr txBox="1"/>
-          <p:nvPr/>
-        </p:nvSpPr>
-        <p:spPr>
-          <a:xfrm>
-            <a:off x="731520" y="6016752"/>
-            <a:ext cx="3026664" cy="292608"/>
-          </a:xfrm>
-          <a:prstGeom prst="rect">
-            <a:avLst/>
-          </a:prstGeom>
-          <a:noFill/>
-          <a:ln/>
-        </p:spPr>
-        <p:txBody>
-          <a:bodyPr wrap="square" lIns="0" tIns="0" rIns="0" bIns="0" rtlCol="0" anchor="ctr"/>
-          <a:lstStyle/>
-          <a:p>
-            <a:pPr indent="0" marL="0">
-              <a:buNone/>
-            </a:pPr>
-            <a:r>
-              <a:rPr lang="en-US" sz="1200" dirty="0">
-                <a:solidFill>
-                  <a:srgbClr val="CBD5E1"/>
-                </a:solidFill>
-                <a:latin typeface="Calibri" pitchFamily="34" charset="0"/>
-                <a:ea typeface="Calibri" pitchFamily="34" charset="-122"/>
-                <a:cs typeface="Calibri" pitchFamily="34" charset="-120"/>
-              </a:rPr>
-              <a:t>single tenant, ~200 events/s, Cloud Run</a:t>
-            </a:r>
-            <a:endParaRPr lang="en-US" sz="1200" dirty="0"/>
-          </a:p>
-        </p:txBody>
-      </p:sp>
       <p:pic>
         <p:nvPicPr>
-          <p:cNvPr id="24" name="Image 2" descr="preencoded.png">    </p:cNvPr>
+          <p:cNvPr id="14" name="Image 4" descr="preencoded.png">    </p:cNvPr>
           <p:cNvPicPr>
             <a:picLocks noChangeAspect="1"/>
           </p:cNvPicPr>
           <p:nvPr/>
         </p:nvPicPr>
         <p:blipFill>
-          <a:blip r:embed="rId3"/>
+          <a:blip r:embed="rId5"/>
           <a:stretch>
             <a:fillRect/>
           </a:stretch>
         </p:blipFill>
         <p:spPr>
           <a:xfrm>
-            <a:off x="4059936" y="5902452"/>
+            <a:off x="5378501" y="1691640"/>
+            <a:ext cx="365760" cy="365760"/>
+          </a:xfrm>
+          <a:prstGeom prst="rect">
+            <a:avLst/>
+          </a:prstGeom>
+        </p:spPr>
+      </p:pic>
+      <p:sp>
+        <p:nvSpPr>
+          <p:cNvPr id="15" name="Text 8"/>
+          <p:cNvSpPr txBox="1"/>
+          <p:nvPr/>
+        </p:nvSpPr>
+        <p:spPr>
+          <a:xfrm>
+            <a:off x="5378501" y="2194560"/>
+            <a:ext cx="1431950" cy="365760"/>
+          </a:xfrm>
+          <a:prstGeom prst="rect">
+            <a:avLst/>
+          </a:prstGeom>
+          <a:noFill/>
+          <a:ln/>
+        </p:spPr>
+        <p:txBody>
+          <a:bodyPr wrap="square" lIns="0" tIns="0" rIns="0" bIns="0" rtlCol="0" anchor="ctr"/>
+          <a:lstStyle/>
+          <a:p>
+            <a:pPr indent="0" marL="0">
+              <a:buNone/>
+            </a:pPr>
+            <a:r>
+              <a:rPr lang="en-US" sz="1800" b="1" dirty="0">
+                <a:solidFill>
+                  <a:srgbClr val="FFFFFF"/>
+                </a:solidFill>
+                <a:latin typeface="Calibri" pitchFamily="34" charset="0"/>
+                <a:ea typeface="Calibri" pitchFamily="34" charset="-122"/>
+                <a:cs typeface="Calibri" pitchFamily="34" charset="-120"/>
+              </a:rPr>
+              <a:t>Agents</a:t>
+            </a:r>
+            <a:endParaRPr lang="en-US" sz="1800" dirty="0"/>
+          </a:p>
+        </p:txBody>
+      </p:sp>
+      <p:sp>
+        <p:nvSpPr>
+          <p:cNvPr id="16" name="Text 9"/>
+          <p:cNvSpPr txBox="1"/>
+          <p:nvPr/>
+        </p:nvSpPr>
+        <p:spPr>
+          <a:xfrm>
+            <a:off x="5378501" y="2560320"/>
+            <a:ext cx="1431950" cy="640080"/>
+          </a:xfrm>
+          <a:prstGeom prst="rect">
+            <a:avLst/>
+          </a:prstGeom>
+          <a:noFill/>
+          <a:ln/>
+        </p:spPr>
+        <p:txBody>
+          <a:bodyPr wrap="square" lIns="0" tIns="0" rIns="0" bIns="0" rtlCol="0" anchor="t"/>
+          <a:lstStyle/>
+          <a:p>
+            <a:pPr indent="0" marL="0">
+              <a:buNone/>
+            </a:pPr>
+            <a:r>
+              <a:rPr lang="en-US" sz="1200" dirty="0">
+                <a:solidFill>
+                  <a:srgbClr val="CBD5E1"/>
+                </a:solidFill>
+                <a:latin typeface="Calibri" pitchFamily="34" charset="0"/>
+                <a:ea typeface="Calibri" pitchFamily="34" charset="-122"/>
+                <a:cs typeface="Calibri" pitchFamily="34" charset="-120"/>
+              </a:rPr>
+              <a:t>Commander plans; specialists investigate</a:t>
+            </a:r>
+            <a:endParaRPr lang="en-US" sz="1200" dirty="0"/>
+          </a:p>
+        </p:txBody>
+      </p:sp>
+      <p:pic>
+        <p:nvPicPr>
+          <p:cNvPr id="17" name="Image 5" descr="preencoded.png">    </p:cNvPr>
+          <p:cNvPicPr>
+            <a:picLocks noChangeAspect="1"/>
+          </p:cNvPicPr>
+          <p:nvPr/>
+        </p:nvPicPr>
+        <p:blipFill>
+          <a:blip r:embed="rId6"/>
+          <a:stretch>
+            <a:fillRect/>
+          </a:stretch>
+        </p:blipFill>
+        <p:spPr>
+          <a:xfrm>
+            <a:off x="7130491" y="2267712"/>
             <a:ext cx="219456" cy="219456"/>
           </a:xfrm>
           <a:prstGeom prst="rect">
@@ -3994,18 +4612,171 @@
       </p:pic>
       <p:sp>
         <p:nvSpPr>
-          <p:cNvPr id="25" name="Scale 2"/>
+          <p:cNvPr id="18" name="Stage 4"/>
           <p:cNvSpPr/>
           <p:nvPr/>
         </p:nvSpPr>
         <p:spPr>
           <a:xfrm>
-            <a:off x="4398264" y="5623560"/>
-            <a:ext cx="3392424" cy="777240"/>
+            <a:off x="7450531" y="1463040"/>
+            <a:ext cx="1889150" cy="1828800"/>
           </a:xfrm>
           <a:prstGeom prst="roundRect">
             <a:avLst>
-              <a:gd name="adj" fmla="val 11765"/>
+              <a:gd name="adj" fmla="val 6000"/>
+            </a:avLst>
+          </a:prstGeom>
+          <a:solidFill>
+            <a:srgbClr val="0F172A"/>
+          </a:solidFill>
+          <a:ln w="12700">
+            <a:solidFill>
+              <a:srgbClr val="0F172A"/>
+            </a:solidFill>
+            <a:prstDash val="solid"/>
+          </a:ln>
+        </p:spPr>
+      </p:sp>
+      <p:pic>
+        <p:nvPicPr>
+          <p:cNvPr id="19" name="Image 6" descr="preencoded.png">    </p:cNvPr>
+          <p:cNvPicPr>
+            <a:picLocks noChangeAspect="1"/>
+          </p:cNvPicPr>
+          <p:nvPr/>
+        </p:nvPicPr>
+        <p:blipFill>
+          <a:blip r:embed="rId7"/>
+          <a:stretch>
+            <a:fillRect/>
+          </a:stretch>
+        </p:blipFill>
+        <p:spPr>
+          <a:xfrm>
+            <a:off x="7679131" y="1691640"/>
+            <a:ext cx="365760" cy="365760"/>
+          </a:xfrm>
+          <a:prstGeom prst="rect">
+            <a:avLst/>
+          </a:prstGeom>
+        </p:spPr>
+      </p:pic>
+      <p:sp>
+        <p:nvSpPr>
+          <p:cNvPr id="20" name="Text 11"/>
+          <p:cNvSpPr txBox="1"/>
+          <p:nvPr/>
+        </p:nvSpPr>
+        <p:spPr>
+          <a:xfrm>
+            <a:off x="7679131" y="2194560"/>
+            <a:ext cx="1431950" cy="365760"/>
+          </a:xfrm>
+          <a:prstGeom prst="rect">
+            <a:avLst/>
+          </a:prstGeom>
+          <a:noFill/>
+          <a:ln/>
+        </p:spPr>
+        <p:txBody>
+          <a:bodyPr wrap="square" lIns="0" tIns="0" rIns="0" bIns="0" rtlCol="0" anchor="ctr"/>
+          <a:lstStyle/>
+          <a:p>
+            <a:pPr indent="0" marL="0">
+              <a:buNone/>
+            </a:pPr>
+            <a:r>
+              <a:rPr lang="en-US" sz="1800" b="1" dirty="0">
+                <a:solidFill>
+                  <a:srgbClr val="FFFFFF"/>
+                </a:solidFill>
+                <a:latin typeface="Calibri" pitchFamily="34" charset="0"/>
+                <a:ea typeface="Calibri" pitchFamily="34" charset="-122"/>
+                <a:cs typeface="Calibri" pitchFamily="34" charset="-120"/>
+              </a:rPr>
+              <a:t>Policy Guard</a:t>
+            </a:r>
+            <a:endParaRPr lang="en-US" sz="1800" dirty="0"/>
+          </a:p>
+        </p:txBody>
+      </p:sp>
+      <p:sp>
+        <p:nvSpPr>
+          <p:cNvPr id="21" name="Text 12"/>
+          <p:cNvSpPr txBox="1"/>
+          <p:nvPr/>
+        </p:nvSpPr>
+        <p:spPr>
+          <a:xfrm>
+            <a:off x="7679131" y="2560320"/>
+            <a:ext cx="1431950" cy="640080"/>
+          </a:xfrm>
+          <a:prstGeom prst="rect">
+            <a:avLst/>
+          </a:prstGeom>
+          <a:noFill/>
+          <a:ln/>
+        </p:spPr>
+        <p:txBody>
+          <a:bodyPr wrap="square" lIns="0" tIns="0" rIns="0" bIns="0" rtlCol="0" anchor="t"/>
+          <a:lstStyle/>
+          <a:p>
+            <a:pPr indent="0" marL="0">
+              <a:buNone/>
+            </a:pPr>
+            <a:r>
+              <a:rPr lang="en-US" sz="1200" dirty="0">
+                <a:solidFill>
+                  <a:srgbClr val="CBD5E1"/>
+                </a:solidFill>
+                <a:latin typeface="Calibri" pitchFamily="34" charset="0"/>
+                <a:ea typeface="Calibri" pitchFamily="34" charset="-122"/>
+                <a:cs typeface="Calibri" pitchFamily="34" charset="-120"/>
+              </a:rPr>
+              <a:t>deterministic veto, caps, allowlists</a:t>
+            </a:r>
+            <a:endParaRPr lang="en-US" sz="1200" dirty="0"/>
+          </a:p>
+        </p:txBody>
+      </p:sp>
+      <p:pic>
+        <p:nvPicPr>
+          <p:cNvPr id="22" name="Image 7" descr="preencoded.png">    </p:cNvPr>
+          <p:cNvPicPr>
+            <a:picLocks noChangeAspect="1"/>
+          </p:cNvPicPr>
+          <p:nvPr/>
+        </p:nvPicPr>
+        <p:blipFill>
+          <a:blip r:embed="rId8"/>
+          <a:stretch>
+            <a:fillRect/>
+          </a:stretch>
+        </p:blipFill>
+        <p:spPr>
+          <a:xfrm>
+            <a:off x="9431122" y="2267712"/>
+            <a:ext cx="219456" cy="219456"/>
+          </a:xfrm>
+          <a:prstGeom prst="rect">
+            <a:avLst/>
+          </a:prstGeom>
+        </p:spPr>
+      </p:pic>
+      <p:sp>
+        <p:nvSpPr>
+          <p:cNvPr id="23" name="Stage 5"/>
+          <p:cNvSpPr/>
+          <p:nvPr/>
+        </p:nvSpPr>
+        <p:spPr>
+          <a:xfrm>
+            <a:off x="9751162" y="1463040"/>
+            <a:ext cx="1889150" cy="1828800"/>
+          </a:xfrm>
+          <a:prstGeom prst="roundRect">
+            <a:avLst>
+              <a:gd name="adj" fmla="val 6000"/>
             </a:avLst>
           </a:prstGeom>
           <a:solidFill>
@@ -4019,102 +4790,24 @@
           </a:ln>
         </p:spPr>
       </p:sp>
-      <p:sp>
-        <p:nvSpPr>
-          <p:cNvPr id="26" name="Text 21"/>
-          <p:cNvSpPr txBox="1"/>
-          <p:nvPr/>
-        </p:nvSpPr>
-        <p:spPr>
-          <a:xfrm>
-            <a:off x="4581144" y="5715000"/>
-            <a:ext cx="3026664" cy="274320"/>
-          </a:xfrm>
-          <a:prstGeom prst="rect">
-            <a:avLst/>
-          </a:prstGeom>
-          <a:noFill/>
-          <a:ln/>
-        </p:spPr>
-        <p:txBody>
-          <a:bodyPr wrap="square" lIns="0" tIns="0" rIns="0" bIns="0" rtlCol="0" anchor="ctr"/>
-          <a:lstStyle/>
-          <a:p>
-            <a:pPr indent="0" marL="0">
-              <a:buNone/>
-            </a:pPr>
-            <a:r>
-              <a:rPr lang="en-US" sz="1400" b="1" dirty="0">
-                <a:solidFill>
-                  <a:srgbClr val="0F172A"/>
-                </a:solidFill>
-                <a:latin typeface="Calibri" pitchFamily="34" charset="0"/>
-                <a:ea typeface="Calibri" pitchFamily="34" charset="-122"/>
-                <a:cs typeface="Calibri" pitchFamily="34" charset="-120"/>
-              </a:rPr>
-              <a:t>MVP</a:t>
-            </a:r>
-            <a:endParaRPr lang="en-US" sz="1400" dirty="0"/>
-          </a:p>
-        </p:txBody>
-      </p:sp>
-      <p:sp>
-        <p:nvSpPr>
-          <p:cNvPr id="27" name="Text 22"/>
-          <p:cNvSpPr txBox="1"/>
-          <p:nvPr/>
-        </p:nvSpPr>
-        <p:spPr>
-          <a:xfrm>
-            <a:off x="4581144" y="6016752"/>
-            <a:ext cx="3026664" cy="292608"/>
-          </a:xfrm>
-          <a:prstGeom prst="rect">
-            <a:avLst/>
-          </a:prstGeom>
-          <a:noFill/>
-          <a:ln/>
-        </p:spPr>
-        <p:txBody>
-          <a:bodyPr wrap="square" lIns="0" tIns="0" rIns="0" bIns="0" rtlCol="0" anchor="ctr"/>
-          <a:lstStyle/>
-          <a:p>
-            <a:pPr indent="0" marL="0">
-              <a:buNone/>
-            </a:pPr>
-            <a:r>
-              <a:rPr lang="en-US" sz="1200" dirty="0">
-                <a:solidFill>
-                  <a:srgbClr val="475569"/>
-                </a:solidFill>
-                <a:latin typeface="Calibri" pitchFamily="34" charset="0"/>
-                <a:ea typeface="Calibri" pitchFamily="34" charset="-122"/>
-                <a:cs typeface="Calibri" pitchFamily="34" charset="-120"/>
-              </a:rPr>
-              <a:t>multi-tenant, ~10k events/s, Dataflow + ADK</a:t>
-            </a:r>
-            <a:endParaRPr lang="en-US" sz="1200" dirty="0"/>
-          </a:p>
-        </p:txBody>
-      </p:sp>
       <p:pic>
         <p:nvPicPr>
-          <p:cNvPr id="28" name="Image 3" descr="preencoded.png">    </p:cNvPr>
+          <p:cNvPr id="24" name="Image 8" descr="preencoded.png">    </p:cNvPr>
           <p:cNvPicPr>
             <a:picLocks noChangeAspect="1"/>
           </p:cNvPicPr>
           <p:nvPr/>
         </p:nvPicPr>
         <p:blipFill>
-          <a:blip r:embed="rId4"/>
+          <a:blip r:embed="rId9"/>
           <a:stretch>
             <a:fillRect/>
           </a:stretch>
         </p:blipFill>
         <p:spPr>
           <a:xfrm>
-            <a:off x="7909560" y="5902452"/>
-            <a:ext cx="219456" cy="219456"/>
+            <a:off x="9979762" y="1691640"/>
+            <a:ext cx="365760" cy="365760"/>
           </a:xfrm>
           <a:prstGeom prst="rect">
             <a:avLst/>
@@ -4123,18 +4816,597 @@
       </p:pic>
       <p:sp>
         <p:nvSpPr>
-          <p:cNvPr id="29" name="Scale 3"/>
+          <p:cNvPr id="25" name="Text 14"/>
+          <p:cNvSpPr txBox="1"/>
+          <p:nvPr/>
+        </p:nvSpPr>
+        <p:spPr>
+          <a:xfrm>
+            <a:off x="9979762" y="2194560"/>
+            <a:ext cx="1431950" cy="365760"/>
+          </a:xfrm>
+          <a:prstGeom prst="rect">
+            <a:avLst/>
+          </a:prstGeom>
+          <a:noFill/>
+          <a:ln/>
+        </p:spPr>
+        <p:txBody>
+          <a:bodyPr wrap="square" lIns="0" tIns="0" rIns="0" bIns="0" rtlCol="0" anchor="ctr"/>
+          <a:lstStyle/>
+          <a:p>
+            <a:pPr indent="0" marL="0">
+              <a:buNone/>
+            </a:pPr>
+            <a:r>
+              <a:rPr lang="en-US" sz="1800" b="1" dirty="0">
+                <a:solidFill>
+                  <a:srgbClr val="0F172A"/>
+                </a:solidFill>
+                <a:latin typeface="Calibri" pitchFamily="34" charset="0"/>
+                <a:ea typeface="Calibri" pitchFamily="34" charset="-122"/>
+                <a:cs typeface="Calibri" pitchFamily="34" charset="-120"/>
+              </a:rPr>
+              <a:t>Actions</a:t>
+            </a:r>
+            <a:endParaRPr lang="en-US" sz="1800" dirty="0"/>
+          </a:p>
+        </p:txBody>
+      </p:sp>
+      <p:sp>
+        <p:nvSpPr>
+          <p:cNvPr id="26" name="Text 15"/>
+          <p:cNvSpPr txBox="1"/>
+          <p:nvPr/>
+        </p:nvSpPr>
+        <p:spPr>
+          <a:xfrm>
+            <a:off x="9979762" y="2560320"/>
+            <a:ext cx="1431950" cy="640080"/>
+          </a:xfrm>
+          <a:prstGeom prst="rect">
+            <a:avLst/>
+          </a:prstGeom>
+          <a:noFill/>
+          <a:ln/>
+        </p:spPr>
+        <p:txBody>
+          <a:bodyPr wrap="square" lIns="0" tIns="0" rIns="0" bIns="0" rtlCol="0" anchor="t"/>
+          <a:lstStyle/>
+          <a:p>
+            <a:pPr indent="0" marL="0">
+              <a:buNone/>
+            </a:pPr>
+            <a:r>
+              <a:rPr lang="en-US" sz="1200" dirty="0">
+                <a:solidFill>
+                  <a:srgbClr val="475569"/>
+                </a:solidFill>
+                <a:latin typeface="Calibri" pitchFamily="34" charset="0"/>
+                <a:ea typeface="Calibri" pitchFamily="34" charset="-122"/>
+                <a:cs typeface="Calibri" pitchFamily="34" charset="-120"/>
+              </a:rPr>
+              <a:t>auto if safe, human approves the rest</a:t>
+            </a:r>
+            <a:endParaRPr lang="en-US" sz="1200" dirty="0"/>
+          </a:p>
+        </p:txBody>
+      </p:sp>
+      <p:sp>
+        <p:nvSpPr>
+          <p:cNvPr id="27" name="Text 16"/>
+          <p:cNvSpPr txBox="1"/>
+          <p:nvPr/>
+        </p:nvSpPr>
+        <p:spPr>
+          <a:xfrm>
+            <a:off x="548640" y="3611880"/>
+            <a:ext cx="7315200" cy="365760"/>
+          </a:xfrm>
+          <a:prstGeom prst="rect">
+            <a:avLst/>
+          </a:prstGeom>
+          <a:noFill/>
+          <a:ln/>
+        </p:spPr>
+        <p:txBody>
+          <a:bodyPr wrap="square" lIns="0" tIns="0" rIns="0" bIns="0" rtlCol="0" anchor="ctr"/>
+          <a:lstStyle/>
+          <a:p>
+            <a:pPr indent="0" marL="0">
+              <a:buNone/>
+            </a:pPr>
+            <a:r>
+              <a:rPr lang="en-US" sz="1800" b="1" dirty="0">
+                <a:solidFill>
+                  <a:srgbClr val="0F172A"/>
+                </a:solidFill>
+                <a:latin typeface="Calibri" pitchFamily="34" charset="0"/>
+                <a:ea typeface="Calibri" pitchFamily="34" charset="-122"/>
+                <a:cs typeface="Calibri" pitchFamily="34" charset="-120"/>
+              </a:rPr>
+              <a:t>Seven agents, each with its own tools and step budget</a:t>
+            </a:r>
+            <a:endParaRPr lang="en-US" sz="1800" dirty="0"/>
+          </a:p>
+        </p:txBody>
+      </p:sp>
+      <p:sp>
+        <p:nvSpPr>
+          <p:cNvPr id="28" name="Agent 1"/>
           <p:cNvSpPr/>
           <p:nvPr/>
         </p:nvSpPr>
         <p:spPr>
           <a:xfrm>
-            <a:off x="8247888" y="5623560"/>
-            <a:ext cx="3392424" cy="777240"/>
+            <a:off x="548640" y="4114800"/>
+            <a:ext cx="1443446" cy="548640"/>
           </a:xfrm>
           <a:prstGeom prst="roundRect">
             <a:avLst>
-              <a:gd name="adj" fmla="val 11765"/>
+              <a:gd name="adj" fmla="val 50000"/>
+            </a:avLst>
+          </a:prstGeom>
+          <a:solidFill>
+            <a:srgbClr val="0F9D8A"/>
+          </a:solidFill>
+          <a:ln w="12700">
+            <a:solidFill>
+              <a:srgbClr val="0F9D8A"/>
+            </a:solidFill>
+            <a:prstDash val="solid"/>
+          </a:ln>
+        </p:spPr>
+      </p:sp>
+      <p:sp>
+        <p:nvSpPr>
+          <p:cNvPr id="29" name="Text 18"/>
+          <p:cNvSpPr txBox="1"/>
+          <p:nvPr/>
+        </p:nvSpPr>
+        <p:spPr>
+          <a:xfrm>
+            <a:off x="548640" y="4114800"/>
+            <a:ext cx="1443446" cy="548640"/>
+          </a:xfrm>
+          <a:prstGeom prst="rect">
+            <a:avLst/>
+          </a:prstGeom>
+          <a:noFill/>
+          <a:ln/>
+        </p:spPr>
+        <p:txBody>
+          <a:bodyPr wrap="square" lIns="0" tIns="0" rIns="0" bIns="0" rtlCol="0" anchor="ctr"/>
+          <a:lstStyle/>
+          <a:p>
+            <a:pPr algn="ctr" indent="0" marL="0">
+              <a:buNone/>
+            </a:pPr>
+            <a:r>
+              <a:rPr lang="en-US" sz="1200" b="1" dirty="0">
+                <a:solidFill>
+                  <a:srgbClr val="FFFFFF"/>
+                </a:solidFill>
+                <a:latin typeface="Calibri" pitchFamily="34" charset="0"/>
+                <a:ea typeface="Calibri" pitchFamily="34" charset="-122"/>
+                <a:cs typeface="Calibri" pitchFamily="34" charset="-120"/>
+              </a:rPr>
+              <a:t>Incident Commander</a:t>
+            </a:r>
+            <a:endParaRPr lang="en-US" sz="1200" dirty="0"/>
+          </a:p>
+        </p:txBody>
+      </p:sp>
+      <p:sp>
+        <p:nvSpPr>
+          <p:cNvPr id="30" name="Agent 2"/>
+          <p:cNvSpPr/>
+          <p:nvPr/>
+        </p:nvSpPr>
+        <p:spPr>
+          <a:xfrm>
+            <a:off x="2156678" y="4114800"/>
+            <a:ext cx="1443446" cy="548640"/>
+          </a:xfrm>
+          <a:prstGeom prst="roundRect">
+            <a:avLst>
+              <a:gd name="adj" fmla="val 50000"/>
+            </a:avLst>
+          </a:prstGeom>
+          <a:solidFill>
+            <a:srgbClr val="FFFFFF"/>
+          </a:solidFill>
+          <a:ln w="12700">
+            <a:solidFill>
+              <a:srgbClr val="E2E8F0"/>
+            </a:solidFill>
+            <a:prstDash val="solid"/>
+          </a:ln>
+        </p:spPr>
+      </p:sp>
+      <p:sp>
+        <p:nvSpPr>
+          <p:cNvPr id="31" name="Text 20"/>
+          <p:cNvSpPr txBox="1"/>
+          <p:nvPr/>
+        </p:nvSpPr>
+        <p:spPr>
+          <a:xfrm>
+            <a:off x="2156678" y="4114800"/>
+            <a:ext cx="1443446" cy="548640"/>
+          </a:xfrm>
+          <a:prstGeom prst="rect">
+            <a:avLst/>
+          </a:prstGeom>
+          <a:noFill/>
+          <a:ln/>
+        </p:spPr>
+        <p:txBody>
+          <a:bodyPr wrap="square" lIns="0" tIns="0" rIns="0" bIns="0" rtlCol="0" anchor="ctr"/>
+          <a:lstStyle/>
+          <a:p>
+            <a:pPr algn="ctr" indent="0" marL="0">
+              <a:buNone/>
+            </a:pPr>
+            <a:r>
+              <a:rPr lang="en-US" sz="1200" b="1" dirty="0">
+                <a:solidFill>
+                  <a:srgbClr val="0F172A"/>
+                </a:solidFill>
+                <a:latin typeface="Calibri" pitchFamily="34" charset="0"/>
+                <a:ea typeface="Calibri" pitchFamily="34" charset="-122"/>
+                <a:cs typeface="Calibri" pitchFamily="34" charset="-120"/>
+              </a:rPr>
+              <a:t>Investigator</a:t>
+            </a:r>
+            <a:endParaRPr lang="en-US" sz="1200" dirty="0"/>
+          </a:p>
+        </p:txBody>
+      </p:sp>
+      <p:sp>
+        <p:nvSpPr>
+          <p:cNvPr id="32" name="Agent 3"/>
+          <p:cNvSpPr/>
+          <p:nvPr/>
+        </p:nvSpPr>
+        <p:spPr>
+          <a:xfrm>
+            <a:off x="3764715" y="4114800"/>
+            <a:ext cx="1443446" cy="548640"/>
+          </a:xfrm>
+          <a:prstGeom prst="roundRect">
+            <a:avLst>
+              <a:gd name="adj" fmla="val 50000"/>
+            </a:avLst>
+          </a:prstGeom>
+          <a:solidFill>
+            <a:srgbClr val="FFFFFF"/>
+          </a:solidFill>
+          <a:ln w="12700">
+            <a:solidFill>
+              <a:srgbClr val="E2E8F0"/>
+            </a:solidFill>
+            <a:prstDash val="solid"/>
+          </a:ln>
+        </p:spPr>
+      </p:sp>
+      <p:sp>
+        <p:nvSpPr>
+          <p:cNvPr id="33" name="Text 22"/>
+          <p:cNvSpPr txBox="1"/>
+          <p:nvPr/>
+        </p:nvSpPr>
+        <p:spPr>
+          <a:xfrm>
+            <a:off x="3764715" y="4114800"/>
+            <a:ext cx="1443446" cy="548640"/>
+          </a:xfrm>
+          <a:prstGeom prst="rect">
+            <a:avLst/>
+          </a:prstGeom>
+          <a:noFill/>
+          <a:ln/>
+        </p:spPr>
+        <p:txBody>
+          <a:bodyPr wrap="square" lIns="0" tIns="0" rIns="0" bIns="0" rtlCol="0" anchor="ctr"/>
+          <a:lstStyle/>
+          <a:p>
+            <a:pPr algn="ctr" indent="0" marL="0">
+              <a:buNone/>
+            </a:pPr>
+            <a:r>
+              <a:rPr lang="en-US" sz="1200" b="1" dirty="0">
+                <a:solidFill>
+                  <a:srgbClr val="0F172A"/>
+                </a:solidFill>
+                <a:latin typeface="Calibri" pitchFamily="34" charset="0"/>
+                <a:ea typeface="Calibri" pitchFamily="34" charset="-122"/>
+                <a:cs typeface="Calibri" pitchFamily="34" charset="-120"/>
+              </a:rPr>
+              <a:t>Historian (RAG)</a:t>
+            </a:r>
+            <a:endParaRPr lang="en-US" sz="1200" dirty="0"/>
+          </a:p>
+        </p:txBody>
+      </p:sp>
+      <p:sp>
+        <p:nvSpPr>
+          <p:cNvPr id="34" name="Agent 4"/>
+          <p:cNvSpPr/>
+          <p:nvPr/>
+        </p:nvSpPr>
+        <p:spPr>
+          <a:xfrm>
+            <a:off x="5372753" y="4114800"/>
+            <a:ext cx="1443446" cy="548640"/>
+          </a:xfrm>
+          <a:prstGeom prst="roundRect">
+            <a:avLst>
+              <a:gd name="adj" fmla="val 50000"/>
+            </a:avLst>
+          </a:prstGeom>
+          <a:solidFill>
+            <a:srgbClr val="FFFFFF"/>
+          </a:solidFill>
+          <a:ln w="12700">
+            <a:solidFill>
+              <a:srgbClr val="E2E8F0"/>
+            </a:solidFill>
+            <a:prstDash val="solid"/>
+          </a:ln>
+        </p:spPr>
+      </p:sp>
+      <p:sp>
+        <p:nvSpPr>
+          <p:cNvPr id="35" name="Text 24"/>
+          <p:cNvSpPr txBox="1"/>
+          <p:nvPr/>
+        </p:nvSpPr>
+        <p:spPr>
+          <a:xfrm>
+            <a:off x="5372753" y="4114800"/>
+            <a:ext cx="1443446" cy="548640"/>
+          </a:xfrm>
+          <a:prstGeom prst="rect">
+            <a:avLst/>
+          </a:prstGeom>
+          <a:noFill/>
+          <a:ln/>
+        </p:spPr>
+        <p:txBody>
+          <a:bodyPr wrap="square" lIns="0" tIns="0" rIns="0" bIns="0" rtlCol="0" anchor="ctr"/>
+          <a:lstStyle/>
+          <a:p>
+            <a:pPr algn="ctr" indent="0" marL="0">
+              <a:buNone/>
+            </a:pPr>
+            <a:r>
+              <a:rPr lang="en-US" sz="1200" b="1" dirty="0">
+                <a:solidFill>
+                  <a:srgbClr val="0F172A"/>
+                </a:solidFill>
+                <a:latin typeface="Calibri" pitchFamily="34" charset="0"/>
+                <a:ea typeface="Calibri" pitchFamily="34" charset="-122"/>
+                <a:cs typeface="Calibri" pitchFamily="34" charset="-120"/>
+              </a:rPr>
+              <a:t>Skeptic</a:t>
+            </a:r>
+            <a:endParaRPr lang="en-US" sz="1200" dirty="0"/>
+          </a:p>
+        </p:txBody>
+      </p:sp>
+      <p:sp>
+        <p:nvSpPr>
+          <p:cNvPr id="36" name="Agent 5"/>
+          <p:cNvSpPr/>
+          <p:nvPr/>
+        </p:nvSpPr>
+        <p:spPr>
+          <a:xfrm>
+            <a:off x="6980791" y="4114800"/>
+            <a:ext cx="1443446" cy="548640"/>
+          </a:xfrm>
+          <a:prstGeom prst="roundRect">
+            <a:avLst>
+              <a:gd name="adj" fmla="val 50000"/>
+            </a:avLst>
+          </a:prstGeom>
+          <a:solidFill>
+            <a:srgbClr val="FFFFFF"/>
+          </a:solidFill>
+          <a:ln w="12700">
+            <a:solidFill>
+              <a:srgbClr val="E2E8F0"/>
+            </a:solidFill>
+            <a:prstDash val="solid"/>
+          </a:ln>
+        </p:spPr>
+      </p:sp>
+      <p:sp>
+        <p:nvSpPr>
+          <p:cNvPr id="37" name="Text 26"/>
+          <p:cNvSpPr txBox="1"/>
+          <p:nvPr/>
+        </p:nvSpPr>
+        <p:spPr>
+          <a:xfrm>
+            <a:off x="6980791" y="4114800"/>
+            <a:ext cx="1443446" cy="548640"/>
+          </a:xfrm>
+          <a:prstGeom prst="rect">
+            <a:avLst/>
+          </a:prstGeom>
+          <a:noFill/>
+          <a:ln/>
+        </p:spPr>
+        <p:txBody>
+          <a:bodyPr wrap="square" lIns="0" tIns="0" rIns="0" bIns="0" rtlCol="0" anchor="ctr"/>
+          <a:lstStyle/>
+          <a:p>
+            <a:pPr algn="ctr" indent="0" marL="0">
+              <a:buNone/>
+            </a:pPr>
+            <a:r>
+              <a:rPr lang="en-US" sz="1200" b="1" dirty="0">
+                <a:solidFill>
+                  <a:srgbClr val="0F172A"/>
+                </a:solidFill>
+                <a:latin typeface="Calibri" pitchFamily="34" charset="0"/>
+                <a:ea typeface="Calibri" pitchFamily="34" charset="-122"/>
+                <a:cs typeface="Calibri" pitchFamily="34" charset="-120"/>
+              </a:rPr>
+              <a:t>Log Analyst</a:t>
+            </a:r>
+            <a:endParaRPr lang="en-US" sz="1200" dirty="0"/>
+          </a:p>
+        </p:txBody>
+      </p:sp>
+      <p:sp>
+        <p:nvSpPr>
+          <p:cNvPr id="38" name="Agent 6"/>
+          <p:cNvSpPr/>
+          <p:nvPr/>
+        </p:nvSpPr>
+        <p:spPr>
+          <a:xfrm>
+            <a:off x="8588829" y="4114800"/>
+            <a:ext cx="1443446" cy="548640"/>
+          </a:xfrm>
+          <a:prstGeom prst="roundRect">
+            <a:avLst>
+              <a:gd name="adj" fmla="val 50000"/>
+            </a:avLst>
+          </a:prstGeom>
+          <a:solidFill>
+            <a:srgbClr val="FFFFFF"/>
+          </a:solidFill>
+          <a:ln w="12700">
+            <a:solidFill>
+              <a:srgbClr val="E2E8F0"/>
+            </a:solidFill>
+            <a:prstDash val="solid"/>
+          </a:ln>
+        </p:spPr>
+      </p:sp>
+      <p:sp>
+        <p:nvSpPr>
+          <p:cNvPr id="39" name="Text 28"/>
+          <p:cNvSpPr txBox="1"/>
+          <p:nvPr/>
+        </p:nvSpPr>
+        <p:spPr>
+          <a:xfrm>
+            <a:off x="8588829" y="4114800"/>
+            <a:ext cx="1443446" cy="548640"/>
+          </a:xfrm>
+          <a:prstGeom prst="rect">
+            <a:avLst/>
+          </a:prstGeom>
+          <a:noFill/>
+          <a:ln/>
+        </p:spPr>
+        <p:txBody>
+          <a:bodyPr wrap="square" lIns="0" tIns="0" rIns="0" bIns="0" rtlCol="0" anchor="ctr"/>
+          <a:lstStyle/>
+          <a:p>
+            <a:pPr algn="ctr" indent="0" marL="0">
+              <a:buNone/>
+            </a:pPr>
+            <a:r>
+              <a:rPr lang="en-US" sz="1200" b="1" dirty="0">
+                <a:solidFill>
+                  <a:srgbClr val="0F172A"/>
+                </a:solidFill>
+                <a:latin typeface="Calibri" pitchFamily="34" charset="0"/>
+                <a:ea typeface="Calibri" pitchFamily="34" charset="-122"/>
+                <a:cs typeface="Calibri" pitchFamily="34" charset="-120"/>
+              </a:rPr>
+              <a:t>Security Sentinel</a:t>
+            </a:r>
+            <a:endParaRPr lang="en-US" sz="1200" dirty="0"/>
+          </a:p>
+        </p:txBody>
+      </p:sp>
+      <p:sp>
+        <p:nvSpPr>
+          <p:cNvPr id="40" name="Agent 7"/>
+          <p:cNvSpPr/>
+          <p:nvPr/>
+        </p:nvSpPr>
+        <p:spPr>
+          <a:xfrm>
+            <a:off x="10196866" y="4114800"/>
+            <a:ext cx="1443446" cy="548640"/>
+          </a:xfrm>
+          <a:prstGeom prst="roundRect">
+            <a:avLst>
+              <a:gd name="adj" fmla="val 50000"/>
+            </a:avLst>
+          </a:prstGeom>
+          <a:solidFill>
+            <a:srgbClr val="FFFFFF"/>
+          </a:solidFill>
+          <a:ln w="12700">
+            <a:solidFill>
+              <a:srgbClr val="E2E8F0"/>
+            </a:solidFill>
+            <a:prstDash val="solid"/>
+          </a:ln>
+        </p:spPr>
+      </p:sp>
+      <p:sp>
+        <p:nvSpPr>
+          <p:cNvPr id="41" name="Text 30"/>
+          <p:cNvSpPr txBox="1"/>
+          <p:nvPr/>
+        </p:nvSpPr>
+        <p:spPr>
+          <a:xfrm>
+            <a:off x="10196866" y="4114800"/>
+            <a:ext cx="1443446" cy="548640"/>
+          </a:xfrm>
+          <a:prstGeom prst="rect">
+            <a:avLst/>
+          </a:prstGeom>
+          <a:noFill/>
+          <a:ln/>
+        </p:spPr>
+        <p:txBody>
+          <a:bodyPr wrap="square" lIns="0" tIns="0" rIns="0" bIns="0" rtlCol="0" anchor="ctr"/>
+          <a:lstStyle/>
+          <a:p>
+            <a:pPr algn="ctr" indent="0" marL="0">
+              <a:buNone/>
+            </a:pPr>
+            <a:r>
+              <a:rPr lang="en-US" sz="1200" b="1" dirty="0">
+                <a:solidFill>
+                  <a:srgbClr val="0F172A"/>
+                </a:solidFill>
+                <a:latin typeface="Calibri" pitchFamily="34" charset="0"/>
+                <a:ea typeface="Calibri" pitchFamily="34" charset="-122"/>
+                <a:cs typeface="Calibri" pitchFamily="34" charset="-120"/>
+              </a:rPr>
+              <a:t>Follow-up</a:t>
+            </a:r>
+            <a:endParaRPr lang="en-US" sz="1200" dirty="0"/>
+          </a:p>
+        </p:txBody>
+      </p:sp>
+      <p:sp>
+        <p:nvSpPr>
+          <p:cNvPr id="42" name="Build status"/>
+          <p:cNvSpPr/>
+          <p:nvPr/>
+        </p:nvSpPr>
+        <p:spPr>
+          <a:xfrm>
+            <a:off x="548640" y="5029200"/>
+            <a:ext cx="11091672" cy="1188720"/>
+          </a:xfrm>
+          <a:prstGeom prst="roundRect">
+            <a:avLst>
+              <a:gd name="adj" fmla="val 7692"/>
             </a:avLst>
           </a:prstGeom>
           <a:solidFill>
@@ -4150,14 +5422,14 @@
       </p:sp>
       <p:sp>
         <p:nvSpPr>
-          <p:cNvPr id="30" name="Text 24"/>
-          <p:cNvSpPr txBox="1"/>
-          <p:nvPr/>
-        </p:nvSpPr>
-        <p:spPr>
-          <a:xfrm>
-            <a:off x="8430768" y="5715000"/>
-            <a:ext cx="3026664" cy="274320"/>
+          <p:cNvPr id="43" name="Text 32"/>
+          <p:cNvSpPr txBox="1"/>
+          <p:nvPr/>
+        </p:nvSpPr>
+        <p:spPr>
+          <a:xfrm>
+            <a:off x="822960" y="5138928"/>
+            <a:ext cx="3240024" cy="548640"/>
           </a:xfrm>
           <a:prstGeom prst="rect">
             <a:avLst/>
@@ -4173,7 +5445,273 @@
               <a:buNone/>
             </a:pPr>
             <a:r>
-              <a:rPr lang="en-US" sz="1400" b="1" dirty="0">
+              <a:rPr lang="en-US" sz="2800" b="1" dirty="0">
+                <a:solidFill>
+                  <a:srgbClr val="B45309"/>
+                </a:solidFill>
+                <a:latin typeface="Calibri" pitchFamily="34" charset="0"/>
+                <a:ea typeface="Calibri" pitchFamily="34" charset="-122"/>
+                <a:cs typeface="Calibri" pitchFamily="34" charset="-120"/>
+              </a:rPr>
+              <a:t>[X] / 15</a:t>
+            </a:r>
+            <a:endParaRPr lang="en-US" sz="2800" dirty="0"/>
+          </a:p>
+        </p:txBody>
+      </p:sp>
+      <p:sp>
+        <p:nvSpPr>
+          <p:cNvPr id="44" name="Text 33"/>
+          <p:cNvSpPr txBox="1"/>
+          <p:nvPr/>
+        </p:nvSpPr>
+        <p:spPr>
+          <a:xfrm>
+            <a:off x="822960" y="5715000"/>
+            <a:ext cx="3240024" cy="320040"/>
+          </a:xfrm>
+          <a:prstGeom prst="rect">
+            <a:avLst/>
+          </a:prstGeom>
+          <a:noFill/>
+          <a:ln/>
+        </p:spPr>
+        <p:txBody>
+          <a:bodyPr wrap="square" lIns="0" tIns="0" rIns="0" bIns="0" rtlCol="0" anchor="ctr"/>
+          <a:lstStyle/>
+          <a:p>
+            <a:pPr indent="0" marL="0">
+              <a:buNone/>
+            </a:pPr>
+            <a:r>
+              <a:rPr lang="en-US" sz="1400" dirty="0">
+                <a:solidFill>
+                  <a:srgbClr val="475569"/>
+                </a:solidFill>
+                <a:latin typeface="Calibri" pitchFamily="34" charset="0"/>
+                <a:ea typeface="Calibri" pitchFamily="34" charset="-122"/>
+                <a:cs typeface="Calibri" pitchFamily="34" charset="-120"/>
+              </a:rPr>
+              <a:t>build phases complete</a:t>
+            </a:r>
+            <a:endParaRPr lang="en-US" sz="1400" dirty="0"/>
+          </a:p>
+        </p:txBody>
+      </p:sp>
+      <p:sp>
+        <p:nvSpPr>
+          <p:cNvPr id="45" name="Text 34"/>
+          <p:cNvSpPr txBox="1"/>
+          <p:nvPr/>
+        </p:nvSpPr>
+        <p:spPr>
+          <a:xfrm>
+            <a:off x="4337304" y="5138928"/>
+            <a:ext cx="3240024" cy="548640"/>
+          </a:xfrm>
+          <a:prstGeom prst="rect">
+            <a:avLst/>
+          </a:prstGeom>
+          <a:noFill/>
+          <a:ln/>
+        </p:spPr>
+        <p:txBody>
+          <a:bodyPr wrap="square" lIns="0" tIns="0" rIns="0" bIns="0" rtlCol="0" anchor="ctr"/>
+          <a:lstStyle/>
+          <a:p>
+            <a:pPr indent="0" marL="0">
+              <a:buNone/>
+            </a:pPr>
+            <a:r>
+              <a:rPr lang="en-US" sz="2800" b="1" dirty="0">
+                <a:solidFill>
+                  <a:srgbClr val="B45309"/>
+                </a:solidFill>
+                <a:latin typeface="Calibri" pitchFamily="34" charset="0"/>
+                <a:ea typeface="Calibri" pitchFamily="34" charset="-122"/>
+                <a:cs typeface="Calibri" pitchFamily="34" charset="-120"/>
+              </a:rPr>
+              <a:t>[X]</a:t>
+            </a:r>
+            <a:endParaRPr lang="en-US" sz="2800" dirty="0"/>
+          </a:p>
+        </p:txBody>
+      </p:sp>
+      <p:sp>
+        <p:nvSpPr>
+          <p:cNvPr id="46" name="Text 35"/>
+          <p:cNvSpPr txBox="1"/>
+          <p:nvPr/>
+        </p:nvSpPr>
+        <p:spPr>
+          <a:xfrm>
+            <a:off x="4337304" y="5715000"/>
+            <a:ext cx="3240024" cy="320040"/>
+          </a:xfrm>
+          <a:prstGeom prst="rect">
+            <a:avLst/>
+          </a:prstGeom>
+          <a:noFill/>
+          <a:ln/>
+        </p:spPr>
+        <p:txBody>
+          <a:bodyPr wrap="square" lIns="0" tIns="0" rIns="0" bIns="0" rtlCol="0" anchor="ctr"/>
+          <a:lstStyle/>
+          <a:p>
+            <a:pPr indent="0" marL="0">
+              <a:buNone/>
+            </a:pPr>
+            <a:r>
+              <a:rPr lang="en-US" sz="1400" dirty="0">
+                <a:solidFill>
+                  <a:srgbClr val="475569"/>
+                </a:solidFill>
+                <a:latin typeface="Calibri" pitchFamily="34" charset="0"/>
+                <a:ea typeface="Calibri" pitchFamily="34" charset="-122"/>
+                <a:cs typeface="Calibri" pitchFamily="34" charset="-120"/>
+              </a:rPr>
+              <a:t>automated tests passing</a:t>
+            </a:r>
+            <a:endParaRPr lang="en-US" sz="1400" dirty="0"/>
+          </a:p>
+        </p:txBody>
+      </p:sp>
+      <p:sp>
+        <p:nvSpPr>
+          <p:cNvPr id="47" name="Text 36"/>
+          <p:cNvSpPr txBox="1"/>
+          <p:nvPr/>
+        </p:nvSpPr>
+        <p:spPr>
+          <a:xfrm>
+            <a:off x="7851648" y="5138928"/>
+            <a:ext cx="3240024" cy="548640"/>
+          </a:xfrm>
+          <a:prstGeom prst="rect">
+            <a:avLst/>
+          </a:prstGeom>
+          <a:noFill/>
+          <a:ln/>
+        </p:spPr>
+        <p:txBody>
+          <a:bodyPr wrap="square" lIns="0" tIns="0" rIns="0" bIns="0" rtlCol="0" anchor="ctr"/>
+          <a:lstStyle/>
+          <a:p>
+            <a:pPr indent="0" marL="0">
+              <a:buNone/>
+            </a:pPr>
+            <a:r>
+              <a:rPr lang="en-US" sz="2800" b="1" dirty="0">
+                <a:solidFill>
+                  <a:srgbClr val="B45309"/>
+                </a:solidFill>
+                <a:latin typeface="Calibri" pitchFamily="34" charset="0"/>
+                <a:ea typeface="Calibri" pitchFamily="34" charset="-122"/>
+                <a:cs typeface="Calibri" pitchFamily="34" charset="-120"/>
+              </a:rPr>
+              <a:t>[status]</a:t>
+            </a:r>
+            <a:endParaRPr lang="en-US" sz="2800" dirty="0"/>
+          </a:p>
+        </p:txBody>
+      </p:sp>
+      <p:sp>
+        <p:nvSpPr>
+          <p:cNvPr id="48" name="Text 37"/>
+          <p:cNvSpPr txBox="1"/>
+          <p:nvPr/>
+        </p:nvSpPr>
+        <p:spPr>
+          <a:xfrm>
+            <a:off x="7851648" y="5715000"/>
+            <a:ext cx="3240024" cy="320040"/>
+          </a:xfrm>
+          <a:prstGeom prst="rect">
+            <a:avLst/>
+          </a:prstGeom>
+          <a:noFill/>
+          <a:ln/>
+        </p:spPr>
+        <p:txBody>
+          <a:bodyPr wrap="square" lIns="0" tIns="0" rIns="0" bIns="0" rtlCol="0" anchor="ctr"/>
+          <a:lstStyle/>
+          <a:p>
+            <a:pPr indent="0" marL="0">
+              <a:buNone/>
+            </a:pPr>
+            <a:r>
+              <a:rPr lang="en-US" sz="1400" dirty="0">
+                <a:solidFill>
+                  <a:srgbClr val="475569"/>
+                </a:solidFill>
+                <a:latin typeface="Calibri" pitchFamily="34" charset="0"/>
+                <a:ea typeface="Calibri" pitchFamily="34" charset="-122"/>
+                <a:cs typeface="Calibri" pitchFamily="34" charset="-120"/>
+              </a:rPr>
+              <a:t>deployed on GCP Cloud Run</a:t>
+            </a:r>
+            <a:endParaRPr lang="en-US" sz="1400" dirty="0"/>
+          </a:p>
+        </p:txBody>
+      </p:sp>
+    </p:spTree>
+  </p:cSld>
+  <p:clrMapOvr>
+    <a:masterClrMapping/>
+  </p:clrMapOvr>
+</p:sld>
+</file>
+
+<file path=ppt/slides/slide5.xml><?xml version="1.0" encoding="utf-8"?>
+<p:sld xmlns:a="http://schemas.openxmlformats.org/drawingml/2006/main" xmlns:r="http://schemas.openxmlformats.org/officeDocument/2006/relationships" xmlns:p="http://schemas.openxmlformats.org/presentationml/2006/main">
+  <p:cSld name="Slide 5">
+    <p:bg>
+      <p:bgPr>
+        <a:solidFill>
+          <a:srgbClr val="FFFFFF"/>
+        </a:solidFill>
+      </p:bgPr>
+    </p:bg>
+    <p:spTree>
+      <p:nvGrpSpPr>
+        <p:cNvPr id="1" name=""/>
+        <p:cNvGrpSpPr/>
+        <p:nvPr/>
+      </p:nvGrpSpPr>
+      <p:grpSpPr>
+        <a:xfrm>
+          <a:off x="0" y="0"/>
+          <a:ext cx="0" cy="0"/>
+          <a:chOff x="0" y="0"/>
+          <a:chExt cx="0" cy="0"/>
+        </a:xfrm>
+      </p:grpSpPr>
+      <p:sp>
+        <p:nvSpPr>
+          <p:cNvPr id="2" name="Title"/>
+          <p:cNvSpPr txBox="1"/>
+          <p:nvPr/>
+        </p:nvSpPr>
+        <p:spPr>
+          <a:xfrm>
+            <a:off x="548640" y="411480"/>
+            <a:ext cx="11091672" cy="731520"/>
+          </a:xfrm>
+          <a:prstGeom prst="rect">
+            <a:avLst/>
+          </a:prstGeom>
+          <a:noFill/>
+          <a:ln/>
+        </p:spPr>
+        <p:txBody>
+          <a:bodyPr wrap="square" lIns="0" tIns="0" rIns="0" bIns="0" rtlCol="0" anchor="ctr"/>
+          <a:lstStyle/>
+          <a:p>
+            <a:pPr indent="0" marL="0">
+              <a:buNone/>
+            </a:pPr>
+            <a:r>
+              <a:rPr lang="en-US" sz="3600" b="1" dirty="0">
                 <a:solidFill>
                   <a:srgbClr val="0F172A"/>
                 </a:solidFill>
@@ -4181,22 +5719,613 @@
                 <a:ea typeface="Calibri" pitchFamily="34" charset="-122"/>
                 <a:cs typeface="Calibri" pitchFamily="34" charset="-120"/>
               </a:rPr>
+              <a:t>From prototype to product</a:t>
+            </a:r>
+            <a:endParaRPr lang="en-US" sz="3600" dirty="0"/>
+          </a:p>
+        </p:txBody>
+      </p:sp>
+      <p:sp>
+        <p:nvSpPr>
+          <p:cNvPr id="3" name="Stage 1"/>
+          <p:cNvSpPr/>
+          <p:nvPr/>
+        </p:nvSpPr>
+        <p:spPr>
+          <a:xfrm>
+            <a:off x="548640" y="1463040"/>
+            <a:ext cx="3392424" cy="2103120"/>
+          </a:xfrm>
+          <a:prstGeom prst="roundRect">
+            <a:avLst>
+              <a:gd name="adj" fmla="val 5217"/>
+            </a:avLst>
+          </a:prstGeom>
+          <a:solidFill>
+            <a:srgbClr val="0F172A"/>
+          </a:solidFill>
+          <a:ln w="12700">
+            <a:solidFill>
+              <a:srgbClr val="0F172A"/>
+            </a:solidFill>
+            <a:prstDash val="solid"/>
+          </a:ln>
+        </p:spPr>
+      </p:sp>
+      <p:sp>
+        <p:nvSpPr>
+          <p:cNvPr id="4" name="Text 2"/>
+          <p:cNvSpPr txBox="1"/>
+          <p:nvPr/>
+        </p:nvSpPr>
+        <p:spPr>
+          <a:xfrm>
+            <a:off x="822960" y="1691640"/>
+            <a:ext cx="2843784" cy="365760"/>
+          </a:xfrm>
+          <a:prstGeom prst="rect">
+            <a:avLst/>
+          </a:prstGeom>
+          <a:noFill/>
+          <a:ln/>
+        </p:spPr>
+        <p:txBody>
+          <a:bodyPr wrap="square" lIns="0" tIns="0" rIns="0" bIns="0" rtlCol="0" anchor="ctr"/>
+          <a:lstStyle/>
+          <a:p>
+            <a:pPr indent="0" marL="0">
+              <a:buNone/>
+            </a:pPr>
+            <a:r>
+              <a:rPr lang="en-US" sz="2000" b="1" dirty="0">
+                <a:solidFill>
+                  <a:srgbClr val="FFFFFF"/>
+                </a:solidFill>
+                <a:latin typeface="Calibri" pitchFamily="34" charset="0"/>
+                <a:ea typeface="Calibri" pitchFamily="34" charset="-122"/>
+                <a:cs typeface="Calibri" pitchFamily="34" charset="-120"/>
+              </a:rPr>
+              <a:t>Prototype (today)</a:t>
+            </a:r>
+            <a:endParaRPr lang="en-US" sz="2000" dirty="0"/>
+          </a:p>
+        </p:txBody>
+      </p:sp>
+      <p:sp>
+        <p:nvSpPr>
+          <p:cNvPr id="5" name="Text 3"/>
+          <p:cNvSpPr txBox="1"/>
+          <p:nvPr/>
+        </p:nvSpPr>
+        <p:spPr>
+          <a:xfrm>
+            <a:off x="822960" y="2194560"/>
+            <a:ext cx="2843784" cy="1280160"/>
+          </a:xfrm>
+          <a:prstGeom prst="rect">
+            <a:avLst/>
+          </a:prstGeom>
+          <a:noFill/>
+          <a:ln/>
+        </p:spPr>
+        <p:txBody>
+          <a:bodyPr wrap="square" lIns="0" tIns="0" rIns="0" bIns="0" rtlCol="0" anchor="t"/>
+          <a:lstStyle/>
+          <a:p>
+            <a:pPr marL="203200" indent="-203200">
+              <a:spcAft>
+                <a:spcPts val="600"/>
+              </a:spcAft>
+              <a:buSzPct val="100000"/>
+              <a:buChar char="•"/>
+            </a:pPr>
+            <a:r>
+              <a:rPr lang="en-US" sz="1400" dirty="0">
+                <a:solidFill>
+                  <a:srgbClr val="CBD5E1"/>
+                </a:solidFill>
+                <a:latin typeface="Calibri" pitchFamily="34" charset="0"/>
+                <a:ea typeface="Calibri" pitchFamily="34" charset="-122"/>
+                <a:cs typeface="Calibri" pitchFamily="34" charset="-120"/>
+              </a:rPr>
+              <a:t>Single tenant, local plus Cloud Run</a:t>
+            </a:r>
+            <a:endParaRPr lang="en-US" sz="1400" dirty="0"/>
+          </a:p>
+          <a:p>
+            <a:pPr marL="203200" indent="-203200">
+              <a:spcAft>
+                <a:spcPts val="600"/>
+              </a:spcAft>
+              <a:buSzPct val="100000"/>
+              <a:buChar char="•"/>
+            </a:pPr>
+            <a:r>
+              <a:rPr lang="en-US" sz="1400" dirty="0">
+                <a:solidFill>
+                  <a:srgbClr val="CBD5E1"/>
+                </a:solidFill>
+                <a:latin typeface="Calibri" pitchFamily="34" charset="0"/>
+                <a:ea typeface="Calibri" pitchFamily="34" charset="-122"/>
+                <a:cs typeface="Calibri" pitchFamily="34" charset="-120"/>
+              </a:rPr>
+              <a:t>~200 events/s</a:t>
+            </a:r>
+            <a:endParaRPr lang="en-US" sz="1400" dirty="0"/>
+          </a:p>
+          <a:p>
+            <a:pPr marL="203200" indent="-203200">
+              <a:spcAft>
+                <a:spcPts val="600"/>
+              </a:spcAft>
+              <a:buSzPct val="100000"/>
+              <a:buChar char="•"/>
+            </a:pPr>
+            <a:r>
+              <a:rPr lang="en-US" sz="1400" dirty="0">
+                <a:solidFill>
+                  <a:srgbClr val="CBD5E1"/>
+                </a:solidFill>
+                <a:latin typeface="Calibri" pitchFamily="34" charset="0"/>
+                <a:ea typeface="Calibri" pitchFamily="34" charset="-122"/>
+                <a:cs typeface="Calibri" pitchFamily="34" charset="-120"/>
+              </a:rPr>
+              <a:t>Simulated fintech platform</a:t>
+            </a:r>
+            <a:endParaRPr lang="en-US" sz="1400" dirty="0"/>
+          </a:p>
+        </p:txBody>
+      </p:sp>
+      <p:pic>
+        <p:nvPicPr>
+          <p:cNvPr id="6" name="Image 0" descr="preencoded.png">    </p:cNvPr>
+          <p:cNvPicPr>
+            <a:picLocks noChangeAspect="1"/>
+          </p:cNvPicPr>
+          <p:nvPr/>
+        </p:nvPicPr>
+        <p:blipFill>
+          <a:blip r:embed="rId1"/>
+          <a:stretch>
+            <a:fillRect/>
+          </a:stretch>
+        </p:blipFill>
+        <p:spPr>
+          <a:xfrm>
+            <a:off x="4059936" y="2404872"/>
+            <a:ext cx="219456" cy="219456"/>
+          </a:xfrm>
+          <a:prstGeom prst="rect">
+            <a:avLst/>
+          </a:prstGeom>
+        </p:spPr>
+      </p:pic>
+      <p:sp>
+        <p:nvSpPr>
+          <p:cNvPr id="7" name="Stage 2"/>
+          <p:cNvSpPr/>
+          <p:nvPr/>
+        </p:nvSpPr>
+        <p:spPr>
+          <a:xfrm>
+            <a:off x="4398264" y="1463040"/>
+            <a:ext cx="3392424" cy="2103120"/>
+          </a:xfrm>
+          <a:prstGeom prst="roundRect">
+            <a:avLst>
+              <a:gd name="adj" fmla="val 5217"/>
+            </a:avLst>
+          </a:prstGeom>
+          <a:solidFill>
+            <a:srgbClr val="F1F5F9"/>
+          </a:solidFill>
+          <a:ln w="12700">
+            <a:solidFill>
+              <a:srgbClr val="F1F5F9"/>
+            </a:solidFill>
+            <a:prstDash val="solid"/>
+          </a:ln>
+        </p:spPr>
+      </p:sp>
+      <p:sp>
+        <p:nvSpPr>
+          <p:cNvPr id="8" name="Text 5"/>
+          <p:cNvSpPr txBox="1"/>
+          <p:nvPr/>
+        </p:nvSpPr>
+        <p:spPr>
+          <a:xfrm>
+            <a:off x="4672584" y="1691640"/>
+            <a:ext cx="2843784" cy="365760"/>
+          </a:xfrm>
+          <a:prstGeom prst="rect">
+            <a:avLst/>
+          </a:prstGeom>
+          <a:noFill/>
+          <a:ln/>
+        </p:spPr>
+        <p:txBody>
+          <a:bodyPr wrap="square" lIns="0" tIns="0" rIns="0" bIns="0" rtlCol="0" anchor="ctr"/>
+          <a:lstStyle/>
+          <a:p>
+            <a:pPr indent="0" marL="0">
+              <a:buNone/>
+            </a:pPr>
+            <a:r>
+              <a:rPr lang="en-US" sz="2000" b="1" dirty="0">
+                <a:solidFill>
+                  <a:srgbClr val="0F172A"/>
+                </a:solidFill>
+                <a:latin typeface="Calibri" pitchFamily="34" charset="0"/>
+                <a:ea typeface="Calibri" pitchFamily="34" charset="-122"/>
+                <a:cs typeface="Calibri" pitchFamily="34" charset="-120"/>
+              </a:rPr>
+              <a:t>MVP</a:t>
+            </a:r>
+            <a:endParaRPr lang="en-US" sz="2000" dirty="0"/>
+          </a:p>
+        </p:txBody>
+      </p:sp>
+      <p:sp>
+        <p:nvSpPr>
+          <p:cNvPr id="9" name="Text 6"/>
+          <p:cNvSpPr txBox="1"/>
+          <p:nvPr/>
+        </p:nvSpPr>
+        <p:spPr>
+          <a:xfrm>
+            <a:off x="4672584" y="2194560"/>
+            <a:ext cx="2843784" cy="1280160"/>
+          </a:xfrm>
+          <a:prstGeom prst="rect">
+            <a:avLst/>
+          </a:prstGeom>
+          <a:noFill/>
+          <a:ln/>
+        </p:spPr>
+        <p:txBody>
+          <a:bodyPr wrap="square" lIns="0" tIns="0" rIns="0" bIns="0" rtlCol="0" anchor="t"/>
+          <a:lstStyle/>
+          <a:p>
+            <a:pPr marL="203200" indent="-203200">
+              <a:spcAft>
+                <a:spcPts val="600"/>
+              </a:spcAft>
+              <a:buSzPct val="100000"/>
+              <a:buChar char="•"/>
+            </a:pPr>
+            <a:r>
+              <a:rPr lang="en-US" sz="1400" dirty="0">
+                <a:solidFill>
+                  <a:srgbClr val="475569"/>
+                </a:solidFill>
+                <a:latin typeface="Calibri" pitchFamily="34" charset="0"/>
+                <a:ea typeface="Calibri" pitchFamily="34" charset="-122"/>
+                <a:cs typeface="Calibri" pitchFamily="34" charset="-120"/>
+              </a:rPr>
+              <a:t>Multi-tenant, SSO, RBAC</a:t>
+            </a:r>
+            <a:endParaRPr lang="en-US" sz="1400" dirty="0"/>
+          </a:p>
+          <a:p>
+            <a:pPr marL="203200" indent="-203200">
+              <a:spcAft>
+                <a:spcPts val="600"/>
+              </a:spcAft>
+              <a:buSzPct val="100000"/>
+              <a:buChar char="•"/>
+            </a:pPr>
+            <a:r>
+              <a:rPr lang="en-US" sz="1400" dirty="0">
+                <a:solidFill>
+                  <a:srgbClr val="475569"/>
+                </a:solidFill>
+                <a:latin typeface="Calibri" pitchFamily="34" charset="0"/>
+                <a:ea typeface="Calibri" pitchFamily="34" charset="-122"/>
+                <a:cs typeface="Calibri" pitchFamily="34" charset="-120"/>
+              </a:rPr>
+              <a:t>~10k events/s, Dataflow + ADK</a:t>
+            </a:r>
+            <a:endParaRPr lang="en-US" sz="1400" dirty="0"/>
+          </a:p>
+          <a:p>
+            <a:pPr marL="203200" indent="-203200">
+              <a:spcAft>
+                <a:spcPts val="600"/>
+              </a:spcAft>
+              <a:buSzPct val="100000"/>
+              <a:buChar char="•"/>
+            </a:pPr>
+            <a:r>
+              <a:rPr lang="en-US" sz="1400" dirty="0">
+                <a:solidFill>
+                  <a:srgbClr val="475569"/>
+                </a:solidFill>
+                <a:latin typeface="Calibri" pitchFamily="34" charset="0"/>
+                <a:ea typeface="Calibri" pitchFamily="34" charset="-122"/>
+                <a:cs typeface="Calibri" pitchFamily="34" charset="-120"/>
+              </a:rPr>
+              <a:t>Datadog, Alertmanager, Jira, PagerDuty</a:t>
+            </a:r>
+            <a:endParaRPr lang="en-US" sz="1400" dirty="0"/>
+          </a:p>
+        </p:txBody>
+      </p:sp>
+      <p:pic>
+        <p:nvPicPr>
+          <p:cNvPr id="10" name="Image 1" descr="preencoded.png">    </p:cNvPr>
+          <p:cNvPicPr>
+            <a:picLocks noChangeAspect="1"/>
+          </p:cNvPicPr>
+          <p:nvPr/>
+        </p:nvPicPr>
+        <p:blipFill>
+          <a:blip r:embed="rId2"/>
+          <a:stretch>
+            <a:fillRect/>
+          </a:stretch>
+        </p:blipFill>
+        <p:spPr>
+          <a:xfrm>
+            <a:off x="7909560" y="2404872"/>
+            <a:ext cx="219456" cy="219456"/>
+          </a:xfrm>
+          <a:prstGeom prst="rect">
+            <a:avLst/>
+          </a:prstGeom>
+        </p:spPr>
+      </p:pic>
+      <p:sp>
+        <p:nvSpPr>
+          <p:cNvPr id="11" name="Stage 3"/>
+          <p:cNvSpPr/>
+          <p:nvPr/>
+        </p:nvSpPr>
+        <p:spPr>
+          <a:xfrm>
+            <a:off x="8247888" y="1463040"/>
+            <a:ext cx="3392424" cy="2103120"/>
+          </a:xfrm>
+          <a:prstGeom prst="roundRect">
+            <a:avLst>
+              <a:gd name="adj" fmla="val 5217"/>
+            </a:avLst>
+          </a:prstGeom>
+          <a:solidFill>
+            <a:srgbClr val="F1F5F9"/>
+          </a:solidFill>
+          <a:ln w="12700">
+            <a:solidFill>
+              <a:srgbClr val="F1F5F9"/>
+            </a:solidFill>
+            <a:prstDash val="solid"/>
+          </a:ln>
+        </p:spPr>
+      </p:sp>
+      <p:sp>
+        <p:nvSpPr>
+          <p:cNvPr id="12" name="Text 8"/>
+          <p:cNvSpPr txBox="1"/>
+          <p:nvPr/>
+        </p:nvSpPr>
+        <p:spPr>
+          <a:xfrm>
+            <a:off x="8522208" y="1691640"/>
+            <a:ext cx="2843784" cy="365760"/>
+          </a:xfrm>
+          <a:prstGeom prst="rect">
+            <a:avLst/>
+          </a:prstGeom>
+          <a:noFill/>
+          <a:ln/>
+        </p:spPr>
+        <p:txBody>
+          <a:bodyPr wrap="square" lIns="0" tIns="0" rIns="0" bIns="0" rtlCol="0" anchor="ctr"/>
+          <a:lstStyle/>
+          <a:p>
+            <a:pPr indent="0" marL="0">
+              <a:buNone/>
+            </a:pPr>
+            <a:r>
+              <a:rPr lang="en-US" sz="2000" b="1" dirty="0">
+                <a:solidFill>
+                  <a:srgbClr val="0F172A"/>
+                </a:solidFill>
+                <a:latin typeface="Calibri" pitchFamily="34" charset="0"/>
+                <a:ea typeface="Calibri" pitchFamily="34" charset="-122"/>
+                <a:cs typeface="Calibri" pitchFamily="34" charset="-120"/>
+              </a:rPr>
               <a:t>Market-ready</a:t>
             </a:r>
+            <a:endParaRPr lang="en-US" sz="2000" dirty="0"/>
+          </a:p>
+        </p:txBody>
+      </p:sp>
+      <p:sp>
+        <p:nvSpPr>
+          <p:cNvPr id="13" name="Text 9"/>
+          <p:cNvSpPr txBox="1"/>
+          <p:nvPr/>
+        </p:nvSpPr>
+        <p:spPr>
+          <a:xfrm>
+            <a:off x="8522208" y="2194560"/>
+            <a:ext cx="2843784" cy="1280160"/>
+          </a:xfrm>
+          <a:prstGeom prst="rect">
+            <a:avLst/>
+          </a:prstGeom>
+          <a:noFill/>
+          <a:ln/>
+        </p:spPr>
+        <p:txBody>
+          <a:bodyPr wrap="square" lIns="0" tIns="0" rIns="0" bIns="0" rtlCol="0" anchor="t"/>
+          <a:lstStyle/>
+          <a:p>
+            <a:pPr marL="203200" indent="-203200">
+              <a:spcAft>
+                <a:spcPts val="600"/>
+              </a:spcAft>
+              <a:buSzPct val="100000"/>
+              <a:buChar char="•"/>
+            </a:pPr>
+            <a:r>
+              <a:rPr lang="en-US" sz="1400" dirty="0">
+                <a:solidFill>
+                  <a:srgbClr val="475569"/>
+                </a:solidFill>
+                <a:latin typeface="Calibri" pitchFamily="34" charset="0"/>
+                <a:ea typeface="Calibri" pitchFamily="34" charset="-122"/>
+                <a:cs typeface="Calibri" pitchFamily="34" charset="-120"/>
+              </a:rPr>
+              <a:t>~500k events/s per region</a:t>
+            </a:r>
             <a:endParaRPr lang="en-US" sz="1400" dirty="0"/>
           </a:p>
-        </p:txBody>
-      </p:sp>
-      <p:sp>
-        <p:nvSpPr>
-          <p:cNvPr id="31" name="Text 25"/>
-          <p:cNvSpPr txBox="1"/>
-          <p:nvPr/>
-        </p:nvSpPr>
-        <p:spPr>
-          <a:xfrm>
-            <a:off x="8430768" y="6016752"/>
-            <a:ext cx="3026664" cy="292608"/>
+          <a:p>
+            <a:pPr marL="203200" indent="-203200">
+              <a:spcAft>
+                <a:spcPts val="600"/>
+              </a:spcAft>
+              <a:buSzPct val="100000"/>
+              <a:buChar char="•"/>
+            </a:pPr>
+            <a:r>
+              <a:rPr lang="en-US" sz="1400" dirty="0">
+                <a:solidFill>
+                  <a:srgbClr val="475569"/>
+                </a:solidFill>
+                <a:latin typeface="Calibri" pitchFamily="34" charset="0"/>
+                <a:ea typeface="Calibri" pitchFamily="34" charset="-122"/>
+                <a:cs typeface="Calibri" pitchFamily="34" charset="-120"/>
+              </a:rPr>
+              <a:t>SOC 2, PCI scope minimisation</a:t>
+            </a:r>
+            <a:endParaRPr lang="en-US" sz="1400" dirty="0"/>
+          </a:p>
+          <a:p>
+            <a:pPr marL="203200" indent="-203200">
+              <a:spcAft>
+                <a:spcPts val="600"/>
+              </a:spcAft>
+              <a:buSzPct val="100000"/>
+              <a:buChar char="•"/>
+            </a:pPr>
+            <a:r>
+              <a:rPr lang="en-US" sz="1400" dirty="0">
+                <a:solidFill>
+                  <a:srgbClr val="475569"/>
+                </a:solidFill>
+                <a:latin typeface="Calibri" pitchFamily="34" charset="0"/>
+                <a:ea typeface="Calibri" pitchFamily="34" charset="-122"/>
+                <a:cs typeface="Calibri" pitchFamily="34" charset="-120"/>
+              </a:rPr>
+              <a:t>Per-tenant models, pattern library</a:t>
+            </a:r>
+            <a:endParaRPr lang="en-US" sz="1400" dirty="0"/>
+          </a:p>
+        </p:txBody>
+      </p:sp>
+      <p:sp>
+        <p:nvSpPr>
+          <p:cNvPr id="14" name="Text 10"/>
+          <p:cNvSpPr txBox="1"/>
+          <p:nvPr/>
+        </p:nvSpPr>
+        <p:spPr>
+          <a:xfrm>
+            <a:off x="548640" y="3749040"/>
+            <a:ext cx="11091672" cy="457200"/>
+          </a:xfrm>
+          <a:prstGeom prst="rect">
+            <a:avLst/>
+          </a:prstGeom>
+          <a:noFill/>
+          <a:ln/>
+        </p:spPr>
+        <p:txBody>
+          <a:bodyPr wrap="square" lIns="0" tIns="0" rIns="0" bIns="0" rtlCol="0" anchor="t"/>
+          <a:lstStyle/>
+          <a:p>
+            <a:pPr indent="0" marL="0">
+              <a:buNone/>
+            </a:pPr>
+            <a:r>
+              <a:rPr lang="en-US" sz="1400" dirty="0">
+                <a:solidFill>
+                  <a:srgbClr val="475569"/>
+                </a:solidFill>
+                <a:latin typeface="Calibri" pitchFamily="34" charset="0"/>
+                <a:ea typeface="Calibri" pitchFamily="34" charset="-122"/>
+                <a:cs typeface="Calibri" pitchFamily="34" charset="-120"/>
+              </a:rPr>
+              <a:t>Business model: SaaS per monitored service per month, plus a premium tier for autonomous security. Sits on top of existing alerts via webhook connectors.</a:t>
+            </a:r>
+            <a:endParaRPr lang="en-US" sz="1400" dirty="0"/>
+          </a:p>
+        </p:txBody>
+      </p:sp>
+      <p:sp>
+        <p:nvSpPr>
+          <p:cNvPr id="15" name="Criterion 1"/>
+          <p:cNvSpPr/>
+          <p:nvPr/>
+        </p:nvSpPr>
+        <p:spPr>
+          <a:xfrm>
+            <a:off x="548640" y="4480560"/>
+            <a:ext cx="2072030" cy="1737360"/>
+          </a:xfrm>
+          <a:prstGeom prst="roundRect">
+            <a:avLst>
+              <a:gd name="adj" fmla="val 5263"/>
+            </a:avLst>
+          </a:prstGeom>
+          <a:solidFill>
+            <a:srgbClr val="FFFFFF"/>
+          </a:solidFill>
+          <a:ln w="12700">
+            <a:solidFill>
+              <a:srgbClr val="E2E8F0"/>
+            </a:solidFill>
+            <a:prstDash val="solid"/>
+          </a:ln>
+        </p:spPr>
+      </p:sp>
+      <p:pic>
+        <p:nvPicPr>
+          <p:cNvPr id="16" name="Image 2" descr="preencoded.png">    </p:cNvPr>
+          <p:cNvPicPr>
+            <a:picLocks noChangeAspect="1"/>
+          </p:cNvPicPr>
+          <p:nvPr/>
+        </p:nvPicPr>
+        <p:blipFill>
+          <a:blip r:embed="rId3"/>
+          <a:stretch>
+            <a:fillRect/>
+          </a:stretch>
+        </p:blipFill>
+        <p:spPr>
+          <a:xfrm>
+            <a:off x="731520" y="4663440"/>
+            <a:ext cx="310896" cy="310896"/>
+          </a:xfrm>
+          <a:prstGeom prst="rect">
+            <a:avLst/>
+          </a:prstGeom>
+        </p:spPr>
+      </p:pic>
+      <p:sp>
+        <p:nvSpPr>
+          <p:cNvPr id="17" name="Text 12"/>
+          <p:cNvSpPr txBox="1"/>
+          <p:nvPr/>
+        </p:nvSpPr>
+        <p:spPr>
+          <a:xfrm>
+            <a:off x="731520" y="5074920"/>
+            <a:ext cx="1706270" cy="320040"/>
           </a:xfrm>
           <a:prstGeom prst="rect">
             <a:avLst/>
@@ -4212,6 +6341,45 @@
               <a:buNone/>
             </a:pPr>
             <a:r>
+              <a:rPr lang="en-US" sz="1500" b="1" dirty="0">
+                <a:solidFill>
+                  <a:srgbClr val="0F172A"/>
+                </a:solidFill>
+                <a:latin typeface="Calibri" pitchFamily="34" charset="0"/>
+                <a:ea typeface="Calibri" pitchFamily="34" charset="-122"/>
+                <a:cs typeface="Calibri" pitchFamily="34" charset="-120"/>
+              </a:rPr>
+              <a:t>Innovation</a:t>
+            </a:r>
+            <a:endParaRPr lang="en-US" sz="1500" dirty="0"/>
+          </a:p>
+        </p:txBody>
+      </p:sp>
+      <p:sp>
+        <p:nvSpPr>
+          <p:cNvPr id="18" name="Text 13"/>
+          <p:cNvSpPr txBox="1"/>
+          <p:nvPr/>
+        </p:nvSpPr>
+        <p:spPr>
+          <a:xfrm>
+            <a:off x="731520" y="5413248"/>
+            <a:ext cx="1706270" cy="685800"/>
+          </a:xfrm>
+          <a:prstGeom prst="rect">
+            <a:avLst/>
+          </a:prstGeom>
+          <a:noFill/>
+          <a:ln/>
+        </p:spPr>
+        <p:txBody>
+          <a:bodyPr wrap="square" lIns="0" tIns="0" rIns="0" bIns="0" rtlCol="0" anchor="t"/>
+          <a:lstStyle/>
+          <a:p>
+            <a:pPr indent="0" marL="0">
+              <a:buNone/>
+            </a:pPr>
+            <a:r>
               <a:rPr lang="en-US" sz="1200" dirty="0">
                 <a:solidFill>
                   <a:srgbClr val="475569"/>
@@ -4220,7 +6388,523 @@
                 <a:ea typeface="Calibri" pitchFamily="34" charset="-122"/>
                 <a:cs typeface="Calibri" pitchFamily="34" charset="-120"/>
               </a:rPr>
-              <a:t>~500k events/s per region, SOC 2, connectors</a:t>
+              <a:t>forecast-triggered, Skeptic, bounded autonomy</a:t>
+            </a:r>
+            <a:endParaRPr lang="en-US" sz="1200" dirty="0"/>
+          </a:p>
+        </p:txBody>
+      </p:sp>
+      <p:sp>
+        <p:nvSpPr>
+          <p:cNvPr id="19" name="Criterion 2"/>
+          <p:cNvSpPr/>
+          <p:nvPr/>
+        </p:nvSpPr>
+        <p:spPr>
+          <a:xfrm>
+            <a:off x="2803550" y="4480560"/>
+            <a:ext cx="2072030" cy="1737360"/>
+          </a:xfrm>
+          <a:prstGeom prst="roundRect">
+            <a:avLst>
+              <a:gd name="adj" fmla="val 5263"/>
+            </a:avLst>
+          </a:prstGeom>
+          <a:solidFill>
+            <a:srgbClr val="FFFFFF"/>
+          </a:solidFill>
+          <a:ln w="12700">
+            <a:solidFill>
+              <a:srgbClr val="E2E8F0"/>
+            </a:solidFill>
+            <a:prstDash val="solid"/>
+          </a:ln>
+        </p:spPr>
+      </p:sp>
+      <p:pic>
+        <p:nvPicPr>
+          <p:cNvPr id="20" name="Image 3" descr="preencoded.png">    </p:cNvPr>
+          <p:cNvPicPr>
+            <a:picLocks noChangeAspect="1"/>
+          </p:cNvPicPr>
+          <p:nvPr/>
+        </p:nvPicPr>
+        <p:blipFill>
+          <a:blip r:embed="rId4"/>
+          <a:stretch>
+            <a:fillRect/>
+          </a:stretch>
+        </p:blipFill>
+        <p:spPr>
+          <a:xfrm>
+            <a:off x="2986430" y="4663440"/>
+            <a:ext cx="310896" cy="310896"/>
+          </a:xfrm>
+          <a:prstGeom prst="rect">
+            <a:avLst/>
+          </a:prstGeom>
+        </p:spPr>
+      </p:pic>
+      <p:sp>
+        <p:nvSpPr>
+          <p:cNvPr id="21" name="Text 15"/>
+          <p:cNvSpPr txBox="1"/>
+          <p:nvPr/>
+        </p:nvSpPr>
+        <p:spPr>
+          <a:xfrm>
+            <a:off x="2986430" y="5074920"/>
+            <a:ext cx="1706270" cy="320040"/>
+          </a:xfrm>
+          <a:prstGeom prst="rect">
+            <a:avLst/>
+          </a:prstGeom>
+          <a:noFill/>
+          <a:ln/>
+        </p:spPr>
+        <p:txBody>
+          <a:bodyPr wrap="square" lIns="0" tIns="0" rIns="0" bIns="0" rtlCol="0" anchor="ctr"/>
+          <a:lstStyle/>
+          <a:p>
+            <a:pPr indent="0" marL="0">
+              <a:buNone/>
+            </a:pPr>
+            <a:r>
+              <a:rPr lang="en-US" sz="1500" b="1" dirty="0">
+                <a:solidFill>
+                  <a:srgbClr val="0F172A"/>
+                </a:solidFill>
+                <a:latin typeface="Calibri" pitchFamily="34" charset="0"/>
+                <a:ea typeface="Calibri" pitchFamily="34" charset="-122"/>
+                <a:cs typeface="Calibri" pitchFamily="34" charset="-120"/>
+              </a:rPr>
+              <a:t>Functionality</a:t>
+            </a:r>
+            <a:endParaRPr lang="en-US" sz="1500" dirty="0"/>
+          </a:p>
+        </p:txBody>
+      </p:sp>
+      <p:sp>
+        <p:nvSpPr>
+          <p:cNvPr id="22" name="Text 16"/>
+          <p:cNvSpPr txBox="1"/>
+          <p:nvPr/>
+        </p:nvSpPr>
+        <p:spPr>
+          <a:xfrm>
+            <a:off x="2986430" y="5413248"/>
+            <a:ext cx="1706270" cy="685800"/>
+          </a:xfrm>
+          <a:prstGeom prst="rect">
+            <a:avLst/>
+          </a:prstGeom>
+          <a:noFill/>
+          <a:ln/>
+        </p:spPr>
+        <p:txBody>
+          <a:bodyPr wrap="square" lIns="0" tIns="0" rIns="0" bIns="0" rtlCol="0" anchor="t"/>
+          <a:lstStyle/>
+          <a:p>
+            <a:pPr indent="0" marL="0">
+              <a:buNone/>
+            </a:pPr>
+            <a:r>
+              <a:rPr lang="en-US" sz="1200" dirty="0">
+                <a:solidFill>
+                  <a:srgbClr val="475569"/>
+                </a:solidFill>
+                <a:latin typeface="Calibri" pitchFamily="34" charset="0"/>
+                <a:ea typeface="Calibri" pitchFamily="34" charset="-122"/>
+                <a:cs typeface="Calibri" pitchFamily="34" charset="-120"/>
+              </a:rPr>
+              <a:t>end to end in the live demo</a:t>
+            </a:r>
+            <a:endParaRPr lang="en-US" sz="1200" dirty="0"/>
+          </a:p>
+        </p:txBody>
+      </p:sp>
+      <p:sp>
+        <p:nvSpPr>
+          <p:cNvPr id="23" name="Criterion 3"/>
+          <p:cNvSpPr/>
+          <p:nvPr/>
+        </p:nvSpPr>
+        <p:spPr>
+          <a:xfrm>
+            <a:off x="5058461" y="4480560"/>
+            <a:ext cx="2072030" cy="1737360"/>
+          </a:xfrm>
+          <a:prstGeom prst="roundRect">
+            <a:avLst>
+              <a:gd name="adj" fmla="val 5263"/>
+            </a:avLst>
+          </a:prstGeom>
+          <a:solidFill>
+            <a:srgbClr val="FFFFFF"/>
+          </a:solidFill>
+          <a:ln w="12700">
+            <a:solidFill>
+              <a:srgbClr val="E2E8F0"/>
+            </a:solidFill>
+            <a:prstDash val="solid"/>
+          </a:ln>
+        </p:spPr>
+      </p:sp>
+      <p:pic>
+        <p:nvPicPr>
+          <p:cNvPr id="24" name="Image 4" descr="preencoded.png">    </p:cNvPr>
+          <p:cNvPicPr>
+            <a:picLocks noChangeAspect="1"/>
+          </p:cNvPicPr>
+          <p:nvPr/>
+        </p:nvPicPr>
+        <p:blipFill>
+          <a:blip r:embed="rId5"/>
+          <a:stretch>
+            <a:fillRect/>
+          </a:stretch>
+        </p:blipFill>
+        <p:spPr>
+          <a:xfrm>
+            <a:off x="5241341" y="4663440"/>
+            <a:ext cx="310896" cy="310896"/>
+          </a:xfrm>
+          <a:prstGeom prst="rect">
+            <a:avLst/>
+          </a:prstGeom>
+        </p:spPr>
+      </p:pic>
+      <p:sp>
+        <p:nvSpPr>
+          <p:cNvPr id="25" name="Text 18"/>
+          <p:cNvSpPr txBox="1"/>
+          <p:nvPr/>
+        </p:nvSpPr>
+        <p:spPr>
+          <a:xfrm>
+            <a:off x="5241341" y="5074920"/>
+            <a:ext cx="1706270" cy="320040"/>
+          </a:xfrm>
+          <a:prstGeom prst="rect">
+            <a:avLst/>
+          </a:prstGeom>
+          <a:noFill/>
+          <a:ln/>
+        </p:spPr>
+        <p:txBody>
+          <a:bodyPr wrap="square" lIns="0" tIns="0" rIns="0" bIns="0" rtlCol="0" anchor="ctr"/>
+          <a:lstStyle/>
+          <a:p>
+            <a:pPr indent="0" marL="0">
+              <a:buNone/>
+            </a:pPr>
+            <a:r>
+              <a:rPr lang="en-US" sz="1500" b="1" dirty="0">
+                <a:solidFill>
+                  <a:srgbClr val="0F172A"/>
+                </a:solidFill>
+                <a:latin typeface="Calibri" pitchFamily="34" charset="0"/>
+                <a:ea typeface="Calibri" pitchFamily="34" charset="-122"/>
+                <a:cs typeface="Calibri" pitchFamily="34" charset="-120"/>
+              </a:rPr>
+              <a:t>Scalability</a:t>
+            </a:r>
+            <a:endParaRPr lang="en-US" sz="1500" dirty="0"/>
+          </a:p>
+        </p:txBody>
+      </p:sp>
+      <p:sp>
+        <p:nvSpPr>
+          <p:cNvPr id="26" name="Text 19"/>
+          <p:cNvSpPr txBox="1"/>
+          <p:nvPr/>
+        </p:nvSpPr>
+        <p:spPr>
+          <a:xfrm>
+            <a:off x="5241341" y="5413248"/>
+            <a:ext cx="1706270" cy="685800"/>
+          </a:xfrm>
+          <a:prstGeom prst="rect">
+            <a:avLst/>
+          </a:prstGeom>
+          <a:noFill/>
+          <a:ln/>
+        </p:spPr>
+        <p:txBody>
+          <a:bodyPr wrap="square" lIns="0" tIns="0" rIns="0" bIns="0" rtlCol="0" anchor="t"/>
+          <a:lstStyle/>
+          <a:p>
+            <a:pPr indent="0" marL="0">
+              <a:buNone/>
+            </a:pPr>
+            <a:r>
+              <a:rPr lang="en-US" sz="1200" dirty="0">
+                <a:solidFill>
+                  <a:srgbClr val="475569"/>
+                </a:solidFill>
+                <a:latin typeface="Calibri" pitchFamily="34" charset="0"/>
+                <a:ea typeface="Calibri" pitchFamily="34" charset="-122"/>
+                <a:cs typeface="Calibri" pitchFamily="34" charset="-120"/>
+              </a:rPr>
+              <a:t>prototype, MVP, market-ready path</a:t>
+            </a:r>
+            <a:endParaRPr lang="en-US" sz="1200" dirty="0"/>
+          </a:p>
+        </p:txBody>
+      </p:sp>
+      <p:sp>
+        <p:nvSpPr>
+          <p:cNvPr id="27" name="Criterion 4"/>
+          <p:cNvSpPr/>
+          <p:nvPr/>
+        </p:nvSpPr>
+        <p:spPr>
+          <a:xfrm>
+            <a:off x="7313371" y="4480560"/>
+            <a:ext cx="2072030" cy="1737360"/>
+          </a:xfrm>
+          <a:prstGeom prst="roundRect">
+            <a:avLst>
+              <a:gd name="adj" fmla="val 5263"/>
+            </a:avLst>
+          </a:prstGeom>
+          <a:solidFill>
+            <a:srgbClr val="FFFFFF"/>
+          </a:solidFill>
+          <a:ln w="12700">
+            <a:solidFill>
+              <a:srgbClr val="E2E8F0"/>
+            </a:solidFill>
+            <a:prstDash val="solid"/>
+          </a:ln>
+        </p:spPr>
+      </p:sp>
+      <p:pic>
+        <p:nvPicPr>
+          <p:cNvPr id="28" name="Image 5" descr="preencoded.png">    </p:cNvPr>
+          <p:cNvPicPr>
+            <a:picLocks noChangeAspect="1"/>
+          </p:cNvPicPr>
+          <p:nvPr/>
+        </p:nvPicPr>
+        <p:blipFill>
+          <a:blip r:embed="rId6"/>
+          <a:stretch>
+            <a:fillRect/>
+          </a:stretch>
+        </p:blipFill>
+        <p:spPr>
+          <a:xfrm>
+            <a:off x="7496251" y="4663440"/>
+            <a:ext cx="310896" cy="310896"/>
+          </a:xfrm>
+          <a:prstGeom prst="rect">
+            <a:avLst/>
+          </a:prstGeom>
+        </p:spPr>
+      </p:pic>
+      <p:sp>
+        <p:nvSpPr>
+          <p:cNvPr id="29" name="Text 21"/>
+          <p:cNvSpPr txBox="1"/>
+          <p:nvPr/>
+        </p:nvSpPr>
+        <p:spPr>
+          <a:xfrm>
+            <a:off x="7496251" y="5074920"/>
+            <a:ext cx="1706270" cy="320040"/>
+          </a:xfrm>
+          <a:prstGeom prst="rect">
+            <a:avLst/>
+          </a:prstGeom>
+          <a:noFill/>
+          <a:ln/>
+        </p:spPr>
+        <p:txBody>
+          <a:bodyPr wrap="square" lIns="0" tIns="0" rIns="0" bIns="0" rtlCol="0" anchor="ctr"/>
+          <a:lstStyle/>
+          <a:p>
+            <a:pPr indent="0" marL="0">
+              <a:buNone/>
+            </a:pPr>
+            <a:r>
+              <a:rPr lang="en-US" sz="1500" b="1" dirty="0">
+                <a:solidFill>
+                  <a:srgbClr val="0F172A"/>
+                </a:solidFill>
+                <a:latin typeface="Calibri" pitchFamily="34" charset="0"/>
+                <a:ea typeface="Calibri" pitchFamily="34" charset="-122"/>
+                <a:cs typeface="Calibri" pitchFamily="34" charset="-120"/>
+              </a:rPr>
+              <a:t>Real-world impact</a:t>
+            </a:r>
+            <a:endParaRPr lang="en-US" sz="1500" dirty="0"/>
+          </a:p>
+        </p:txBody>
+      </p:sp>
+      <p:sp>
+        <p:nvSpPr>
+          <p:cNvPr id="30" name="Text 22"/>
+          <p:cNvSpPr txBox="1"/>
+          <p:nvPr/>
+        </p:nvSpPr>
+        <p:spPr>
+          <a:xfrm>
+            <a:off x="7496251" y="5413248"/>
+            <a:ext cx="1706270" cy="685800"/>
+          </a:xfrm>
+          <a:prstGeom prst="rect">
+            <a:avLst/>
+          </a:prstGeom>
+          <a:noFill/>
+          <a:ln/>
+        </p:spPr>
+        <p:txBody>
+          <a:bodyPr wrap="square" lIns="0" tIns="0" rIns="0" bIns="0" rtlCol="0" anchor="t"/>
+          <a:lstStyle/>
+          <a:p>
+            <a:pPr indent="0" marL="0">
+              <a:buNone/>
+            </a:pPr>
+            <a:r>
+              <a:rPr lang="en-US" sz="1200" dirty="0">
+                <a:solidFill>
+                  <a:srgbClr val="475569"/>
+                </a:solidFill>
+                <a:latin typeface="Calibri" pitchFamily="34" charset="0"/>
+                <a:ea typeface="Calibri" pitchFamily="34" charset="-122"/>
+                <a:cs typeface="Calibri" pitchFamily="34" charset="-120"/>
+              </a:rPr>
+              <a:t>[X] min earlier, [X]% fewer false pages</a:t>
+            </a:r>
+            <a:endParaRPr lang="en-US" sz="1200" dirty="0"/>
+          </a:p>
+        </p:txBody>
+      </p:sp>
+      <p:sp>
+        <p:nvSpPr>
+          <p:cNvPr id="31" name="Criterion 5"/>
+          <p:cNvSpPr/>
+          <p:nvPr/>
+        </p:nvSpPr>
+        <p:spPr>
+          <a:xfrm>
+            <a:off x="9568282" y="4480560"/>
+            <a:ext cx="2072030" cy="1737360"/>
+          </a:xfrm>
+          <a:prstGeom prst="roundRect">
+            <a:avLst>
+              <a:gd name="adj" fmla="val 5263"/>
+            </a:avLst>
+          </a:prstGeom>
+          <a:solidFill>
+            <a:srgbClr val="FFFFFF"/>
+          </a:solidFill>
+          <a:ln w="12700">
+            <a:solidFill>
+              <a:srgbClr val="E2E8F0"/>
+            </a:solidFill>
+            <a:prstDash val="solid"/>
+          </a:ln>
+        </p:spPr>
+      </p:sp>
+      <p:pic>
+        <p:nvPicPr>
+          <p:cNvPr id="32" name="Image 6" descr="preencoded.png">    </p:cNvPr>
+          <p:cNvPicPr>
+            <a:picLocks noChangeAspect="1"/>
+          </p:cNvPicPr>
+          <p:nvPr/>
+        </p:nvPicPr>
+        <p:blipFill>
+          <a:blip r:embed="rId7"/>
+          <a:stretch>
+            <a:fillRect/>
+          </a:stretch>
+        </p:blipFill>
+        <p:spPr>
+          <a:xfrm>
+            <a:off x="9751162" y="4663440"/>
+            <a:ext cx="310896" cy="310896"/>
+          </a:xfrm>
+          <a:prstGeom prst="rect">
+            <a:avLst/>
+          </a:prstGeom>
+        </p:spPr>
+      </p:pic>
+      <p:sp>
+        <p:nvSpPr>
+          <p:cNvPr id="33" name="Text 24"/>
+          <p:cNvSpPr txBox="1"/>
+          <p:nvPr/>
+        </p:nvSpPr>
+        <p:spPr>
+          <a:xfrm>
+            <a:off x="9751162" y="5074920"/>
+            <a:ext cx="1706270" cy="320040"/>
+          </a:xfrm>
+          <a:prstGeom prst="rect">
+            <a:avLst/>
+          </a:prstGeom>
+          <a:noFill/>
+          <a:ln/>
+        </p:spPr>
+        <p:txBody>
+          <a:bodyPr wrap="square" lIns="0" tIns="0" rIns="0" bIns="0" rtlCol="0" anchor="ctr"/>
+          <a:lstStyle/>
+          <a:p>
+            <a:pPr indent="0" marL="0">
+              <a:buNone/>
+            </a:pPr>
+            <a:r>
+              <a:rPr lang="en-US" sz="1500" b="1" dirty="0">
+                <a:solidFill>
+                  <a:srgbClr val="0F172A"/>
+                </a:solidFill>
+                <a:latin typeface="Calibri" pitchFamily="34" charset="0"/>
+                <a:ea typeface="Calibri" pitchFamily="34" charset="-122"/>
+                <a:cs typeface="Calibri" pitchFamily="34" charset="-120"/>
+              </a:rPr>
+              <a:t>Technical execution</a:t>
+            </a:r>
+            <a:endParaRPr lang="en-US" sz="1500" dirty="0"/>
+          </a:p>
+        </p:txBody>
+      </p:sp>
+      <p:sp>
+        <p:nvSpPr>
+          <p:cNvPr id="34" name="Text 25"/>
+          <p:cNvSpPr txBox="1"/>
+          <p:nvPr/>
+        </p:nvSpPr>
+        <p:spPr>
+          <a:xfrm>
+            <a:off x="9751162" y="5413248"/>
+            <a:ext cx="1706270" cy="685800"/>
+          </a:xfrm>
+          <a:prstGeom prst="rect">
+            <a:avLst/>
+          </a:prstGeom>
+          <a:noFill/>
+          <a:ln/>
+        </p:spPr>
+        <p:txBody>
+          <a:bodyPr wrap="square" lIns="0" tIns="0" rIns="0" bIns="0" rtlCol="0" anchor="t"/>
+          <a:lstStyle/>
+          <a:p>
+            <a:pPr indent="0" marL="0">
+              <a:buNone/>
+            </a:pPr>
+            <a:r>
+              <a:rPr lang="en-US" sz="1200" dirty="0">
+                <a:solidFill>
+                  <a:srgbClr val="475569"/>
+                </a:solidFill>
+                <a:latin typeface="Calibri" pitchFamily="34" charset="0"/>
+                <a:ea typeface="Calibri" pitchFamily="34" charset="-122"/>
+                <a:cs typeface="Calibri" pitchFamily="34" charset="-120"/>
+              </a:rPr>
+              <a:t>7 agents, Policy Guard, GCP</a:t>
             </a:r>
             <a:endParaRPr lang="en-US" sz="1200" dirty="0"/>
           </a:p>

</xml_diff>